<commit_message>
Regenerate decision-pack PPTX with project theme
</commit_message>
<xml_diff>
--- a/docs/study/10-mvp-specs/decision-pack.pptx
+++ b/docs/study/10-mvp-specs/decision-pack.pptx
@@ -1,6 +1,6 @@
 
 <file path=ppt/presentation.xml><?xml version="1.0" encoding="utf-8"?>
-<p:presentation xmlns:a="http://schemas.openxmlformats.org/drawingml/2006/main" xmlns:p="http://schemas.openxmlformats.org/presentationml/2006/main" xmlns:r="http://schemas.openxmlformats.org/officeDocument/2006/relationships" autoCompressPictures="0" saveSubsetFonts="1">
+<p:presentation xmlns:a="http://schemas.openxmlformats.org/drawingml/2006/main" xmlns:p="http://schemas.openxmlformats.org/presentationml/2006/main" xmlns:r="http://schemas.openxmlformats.org/officeDocument/2006/relationships">
   <p:sldMasterIdLst>
     <p:sldMasterId id="2147483648" r:id="rId1"/>
   </p:sldMasterIdLst>
@@ -17,119 +17,8 @@
     <p:sldId id="265" r:id="rId11"/>
     <p:sldId id="266" r:id="rId12"/>
   </p:sldIdLst>
-  <p:sldSz cx="9144000" cy="5143500" type="screen16x9"/>
+  <p:sldSz cx="12192000" cy="6858000" type="wide"/>
   <p:notesSz cx="6858000" cy="9144000"/>
-  <p:defaultTextStyle>
-    <a:defPPr>
-      <a:defRPr lang="en-US"/>
-    </a:defPPr>
-    <a:lvl1pPr algn="l" defTabSz="457200" eaLnBrk="1" hangingPunct="1" latinLnBrk="0" marL="0" rtl="0">
-      <a:defRPr kern="1200" sz="1800">
-        <a:solidFill>
-          <a:schemeClr val="tx1"/>
-        </a:solidFill>
-        <a:latin typeface="+mn-lt"/>
-        <a:ea typeface="+mn-ea"/>
-        <a:cs typeface="+mn-cs"/>
-      </a:defRPr>
-    </a:lvl1pPr>
-    <a:lvl2pPr algn="l" defTabSz="457200" eaLnBrk="1" hangingPunct="1" latinLnBrk="0" marL="457200" rtl="0">
-      <a:defRPr kern="1200" sz="1800">
-        <a:solidFill>
-          <a:schemeClr val="tx1"/>
-        </a:solidFill>
-        <a:latin typeface="+mn-lt"/>
-        <a:ea typeface="+mn-ea"/>
-        <a:cs typeface="+mn-cs"/>
-      </a:defRPr>
-    </a:lvl2pPr>
-    <a:lvl3pPr algn="l" defTabSz="457200" eaLnBrk="1" hangingPunct="1" latinLnBrk="0" marL="914400" rtl="0">
-      <a:defRPr kern="1200" sz="1800">
-        <a:solidFill>
-          <a:schemeClr val="tx1"/>
-        </a:solidFill>
-        <a:latin typeface="+mn-lt"/>
-        <a:ea typeface="+mn-ea"/>
-        <a:cs typeface="+mn-cs"/>
-      </a:defRPr>
-    </a:lvl3pPr>
-    <a:lvl4pPr algn="l" defTabSz="457200" eaLnBrk="1" hangingPunct="1" latinLnBrk="0" marL="1371600" rtl="0">
-      <a:defRPr kern="1200" sz="1800">
-        <a:solidFill>
-          <a:schemeClr val="tx1"/>
-        </a:solidFill>
-        <a:latin typeface="+mn-lt"/>
-        <a:ea typeface="+mn-ea"/>
-        <a:cs typeface="+mn-cs"/>
-      </a:defRPr>
-    </a:lvl4pPr>
-    <a:lvl5pPr algn="l" defTabSz="457200" eaLnBrk="1" hangingPunct="1" latinLnBrk="0" marL="1828800" rtl="0">
-      <a:defRPr kern="1200" sz="1800">
-        <a:solidFill>
-          <a:schemeClr val="tx1"/>
-        </a:solidFill>
-        <a:latin typeface="+mn-lt"/>
-        <a:ea typeface="+mn-ea"/>
-        <a:cs typeface="+mn-cs"/>
-      </a:defRPr>
-    </a:lvl5pPr>
-    <a:lvl6pPr algn="l" defTabSz="457200" eaLnBrk="1" hangingPunct="1" latinLnBrk="0" marL="2286000" rtl="0">
-      <a:defRPr kern="1200" sz="1800">
-        <a:solidFill>
-          <a:schemeClr val="tx1"/>
-        </a:solidFill>
-        <a:latin typeface="+mn-lt"/>
-        <a:ea typeface="+mn-ea"/>
-        <a:cs typeface="+mn-cs"/>
-      </a:defRPr>
-    </a:lvl6pPr>
-    <a:lvl7pPr algn="l" defTabSz="457200" eaLnBrk="1" hangingPunct="1" latinLnBrk="0" marL="2743200" rtl="0">
-      <a:defRPr kern="1200" sz="1800">
-        <a:solidFill>
-          <a:schemeClr val="tx1"/>
-        </a:solidFill>
-        <a:latin typeface="+mn-lt"/>
-        <a:ea typeface="+mn-ea"/>
-        <a:cs typeface="+mn-cs"/>
-      </a:defRPr>
-    </a:lvl7pPr>
-    <a:lvl8pPr algn="l" defTabSz="457200" eaLnBrk="1" hangingPunct="1" latinLnBrk="0" marL="3200400" rtl="0">
-      <a:defRPr kern="1200" sz="1800">
-        <a:solidFill>
-          <a:schemeClr val="tx1"/>
-        </a:solidFill>
-        <a:latin typeface="+mn-lt"/>
-        <a:ea typeface="+mn-ea"/>
-        <a:cs typeface="+mn-cs"/>
-      </a:defRPr>
-    </a:lvl8pPr>
-    <a:lvl9pPr algn="l" defTabSz="457200" eaLnBrk="1" hangingPunct="1" latinLnBrk="0" marL="3657600" rtl="0">
-      <a:defRPr kern="1200" sz="1800">
-        <a:solidFill>
-          <a:schemeClr val="tx1"/>
-        </a:solidFill>
-        <a:latin typeface="+mn-lt"/>
-        <a:ea typeface="+mn-ea"/>
-        <a:cs typeface="+mn-cs"/>
-      </a:defRPr>
-    </a:lvl9pPr>
-  </p:defaultTextStyle>
-  <p:extLst>
-    <p:ext uri="{EFAFB233-063F-42B5-8137-9DF3F51BA10A}">
-      <p15:sldGuideLst xmlns:p15="http://schemas.microsoft.com/office/powerpoint/2012/main">
-        <p15:guide id="1" orient="horz" pos="1620" userDrawn="1">
-          <p15:clr>
-            <a:srgbClr val="A4A3A4"/>
-          </p15:clr>
-        </p15:guide>
-        <p15:guide id="2" pos="2880" userDrawn="1">
-          <p15:clr>
-            <a:srgbClr val="A4A3A4"/>
-          </p15:clr>
-        </p15:guide>
-      </p15:sldGuideLst>
-    </p:ext>
-  </p:extLst>
 </p:presentation>
 </file>
 
@@ -2578,11 +2467,6 @@
 <file path=ppt/slideMasters/slideMaster1.xml><?xml version="1.0" encoding="utf-8"?>
 <p:sldMaster xmlns:a="http://schemas.openxmlformats.org/drawingml/2006/main" xmlns:p="http://schemas.openxmlformats.org/presentationml/2006/main" xmlns:r="http://schemas.openxmlformats.org/officeDocument/2006/relationships">
   <p:cSld>
-    <p:bg>
-      <p:bgRef idx="1001">
-        <a:schemeClr val="bg1"/>
-      </p:bgRef>
-    </p:bg>
     <p:spTree>
       <p:nvGrpSpPr>
         <p:cNvPr id="1" name=""/>
@@ -2597,488 +2481,21 @@
           <a:chExt cx="0" cy="0"/>
         </a:xfrm>
       </p:grpSpPr>
-      <p:sp>
-        <p:nvSpPr>
-          <p:cNvPr id="2" name="Title Placeholder 1"/>
-          <p:cNvSpPr>
-            <a:spLocks noGrp="1"/>
-          </p:cNvSpPr>
-          <p:nvPr>
-            <p:ph type="title"/>
-          </p:nvPr>
-        </p:nvSpPr>
-        <p:spPr>
-          <a:xfrm>
-            <a:off x="457200" y="205979"/>
-            <a:ext cx="8229600" cy="857250"/>
-          </a:xfrm>
-          <a:prstGeom prst="rect">
-            <a:avLst/>
-          </a:prstGeom>
-        </p:spPr>
-        <p:txBody>
-          <a:bodyPr anchor="ctr" bIns="45720" lIns="91440" rIns="91440" rtlCol="0" tIns="45720" vert="horz">
-            <a:normAutofit/>
-          </a:bodyPr>
-          <a:lstStyle/>
-          <a:p>
-            <a:r>
-              <a:rPr lang="en-US"/>
-              <a:t>Click to edit Master title style</a:t>
-            </a:r>
-          </a:p>
-        </p:txBody>
-      </p:sp>
-      <p:sp>
-        <p:nvSpPr>
-          <p:cNvPr id="3" name="Text Placeholder 2"/>
-          <p:cNvSpPr>
-            <a:spLocks noGrp="1"/>
-          </p:cNvSpPr>
-          <p:nvPr>
-            <p:ph idx="1" type="body"/>
-          </p:nvPr>
-        </p:nvSpPr>
-        <p:spPr>
-          <a:xfrm>
-            <a:off x="457200" y="1200151"/>
-            <a:ext cx="8229600" cy="3394472"/>
-          </a:xfrm>
-          <a:prstGeom prst="rect">
-            <a:avLst/>
-          </a:prstGeom>
-        </p:spPr>
-        <p:txBody>
-          <a:bodyPr bIns="45720" lIns="91440" rIns="91440" rtlCol="0" tIns="45720" vert="horz">
-            <a:normAutofit/>
-          </a:bodyPr>
-          <a:lstStyle/>
-          <a:p>
-            <a:pPr lvl="0"/>
-            <a:r>
-              <a:rPr lang="en-US"/>
-              <a:t>Click to edit Master text styles</a:t>
-            </a:r>
-          </a:p>
-          <a:p>
-            <a:pPr lvl="1"/>
-            <a:r>
-              <a:rPr lang="en-US"/>
-              <a:t>Second level</a:t>
-            </a:r>
-          </a:p>
-          <a:p>
-            <a:pPr lvl="2"/>
-            <a:r>
-              <a:rPr lang="en-US"/>
-              <a:t>Third level</a:t>
-            </a:r>
-          </a:p>
-          <a:p>
-            <a:pPr lvl="3"/>
-            <a:r>
-              <a:rPr lang="en-US"/>
-              <a:t>Fourth level</a:t>
-            </a:r>
-          </a:p>
-          <a:p>
-            <a:pPr lvl="4"/>
-            <a:r>
-              <a:rPr lang="en-US"/>
-              <a:t>Fifth level</a:t>
-            </a:r>
-          </a:p>
-        </p:txBody>
-      </p:sp>
-      <p:sp>
-        <p:nvSpPr>
-          <p:cNvPr id="4" name="Date Placeholder 3"/>
-          <p:cNvSpPr>
-            <a:spLocks noGrp="1"/>
-          </p:cNvSpPr>
-          <p:nvPr>
-            <p:ph idx="2" sz="half" type="dt"/>
-          </p:nvPr>
-        </p:nvSpPr>
-        <p:spPr>
-          <a:xfrm>
-            <a:off x="457200" y="4767263"/>
-            <a:ext cx="2133600" cy="273844"/>
-          </a:xfrm>
-          <a:prstGeom prst="rect">
-            <a:avLst/>
-          </a:prstGeom>
-        </p:spPr>
-        <p:txBody>
-          <a:bodyPr anchor="ctr" bIns="45720" lIns="91440" rIns="91440" rtlCol="0" tIns="45720" vert="horz"/>
-          <a:lstStyle>
-            <a:lvl1pPr algn="l">
-              <a:defRPr sz="900">
-                <a:solidFill>
-                  <a:schemeClr val="tx1">
-                    <a:tint val="75000"/>
-                  </a:schemeClr>
-                </a:solidFill>
-              </a:defRPr>
-            </a:lvl1pPr>
-          </a:lstStyle>
-          <a:p>
-            <a:fld id="{241EB5C9-1307-BA42-ABA2-0BC069CD8E7F}" type="datetimeFigureOut">
-              <a:rPr lang="en-US" smtClean="0"/>
-              <a:t>1/2/22</a:t>
-            </a:fld>
-            <a:endParaRPr lang="en-US"/>
-          </a:p>
-        </p:txBody>
-      </p:sp>
-      <p:sp>
-        <p:nvSpPr>
-          <p:cNvPr id="5" name="Footer Placeholder 4"/>
-          <p:cNvSpPr>
-            <a:spLocks noGrp="1"/>
-          </p:cNvSpPr>
-          <p:nvPr>
-            <p:ph idx="3" sz="quarter" type="ftr"/>
-          </p:nvPr>
-        </p:nvSpPr>
-        <p:spPr>
-          <a:xfrm>
-            <a:off x="3124200" y="4767263"/>
-            <a:ext cx="2895600" cy="273844"/>
-          </a:xfrm>
-          <a:prstGeom prst="rect">
-            <a:avLst/>
-          </a:prstGeom>
-        </p:spPr>
-        <p:txBody>
-          <a:bodyPr anchor="ctr" bIns="45720" lIns="91440" rIns="91440" rtlCol="0" tIns="45720" vert="horz"/>
-          <a:lstStyle>
-            <a:lvl1pPr algn="ctr">
-              <a:defRPr sz="900">
-                <a:solidFill>
-                  <a:schemeClr val="tx1">
-                    <a:tint val="75000"/>
-                  </a:schemeClr>
-                </a:solidFill>
-              </a:defRPr>
-            </a:lvl1pPr>
-          </a:lstStyle>
-          <a:p>
-            <a:endParaRPr lang="en-US"/>
-          </a:p>
-        </p:txBody>
-      </p:sp>
-      <p:sp>
-        <p:nvSpPr>
-          <p:cNvPr id="6" name="Slide Number Placeholder 5"/>
-          <p:cNvSpPr>
-            <a:spLocks noGrp="1"/>
-          </p:cNvSpPr>
-          <p:nvPr>
-            <p:ph idx="4" sz="quarter" type="sldNum"/>
-          </p:nvPr>
-        </p:nvSpPr>
-        <p:spPr>
-          <a:xfrm>
-            <a:off x="6553200" y="4767263"/>
-            <a:ext cx="2133600" cy="273844"/>
-          </a:xfrm>
-          <a:prstGeom prst="rect">
-            <a:avLst/>
-          </a:prstGeom>
-        </p:spPr>
-        <p:txBody>
-          <a:bodyPr anchor="ctr" bIns="45720" lIns="91440" rIns="91440" rtlCol="0" tIns="45720" vert="horz"/>
-          <a:lstStyle>
-            <a:lvl1pPr algn="r">
-              <a:defRPr sz="900">
-                <a:solidFill>
-                  <a:schemeClr val="tx1">
-                    <a:tint val="75000"/>
-                  </a:schemeClr>
-                </a:solidFill>
-              </a:defRPr>
-            </a:lvl1pPr>
-          </a:lstStyle>
-          <a:p>
-            <a:fld id="{C5EF2332-01BF-834F-8236-50238282D533}" type="slidenum">
-              <a:rPr lang="en-US" smtClean="0"/>
-              <a:t>‹#›</a:t>
-            </a:fld>
-            <a:endParaRPr lang="en-US"/>
-          </a:p>
-        </p:txBody>
-      </p:sp>
     </p:spTree>
-    <p:extLst>
-      <p:ext uri="{BB962C8B-B14F-4D97-AF65-F5344CB8AC3E}">
-        <p14:creationId xmlns:p14="http://schemas.microsoft.com/office/powerpoint/2010/main" val="3676200875"/>
-      </p:ext>
-    </p:extLst>
   </p:cSld>
   <p:clrMap accent1="accent1" accent2="accent2" accent3="accent3" accent4="accent4" accent5="accent5" accent6="accent6" bg1="lt1" bg2="lt2" folHlink="folHlink" hlink="hlink" tx1="dk1" tx2="dk2"/>
   <p:sldLayoutIdLst>
     <p:sldLayoutId id="2147483649" r:id="rId1"/>
-    <p:sldLayoutId id="2147483650" r:id="rId2"/>
-    <p:sldLayoutId id="2147483651" r:id="rId3"/>
-    <p:sldLayoutId id="2147483652" r:id="rId4"/>
-    <p:sldLayoutId id="2147483653" r:id="rId5"/>
-    <p:sldLayoutId id="2147483654" r:id="rId6"/>
-    <p:sldLayoutId id="2147483655" r:id="rId7"/>
-    <p:sldLayoutId id="2147483656" r:id="rId8"/>
-    <p:sldLayoutId id="2147483657" r:id="rId9"/>
-    <p:sldLayoutId id="2147483658" r:id="rId10"/>
-    <p:sldLayoutId id="2147483659" r:id="rId11"/>
+    <p:sldLayoutId id="2147483654" r:id="rId7"/>
+    <p:sldLayoutId id="2147483653" r:id="rId6"/>
+    <p:sldLayoutId id="2147483652" r:id="rId5"/>
+    <p:sldLayoutId id="2147483651" r:id="rId4"/>
+    <p:sldLayoutId id="2147483650" r:id="rId3"/>
   </p:sldLayoutIdLst>
   <p:txStyles>
-    <p:titleStyle>
-      <a:lvl1pPr algn="ctr" defTabSz="342900" eaLnBrk="1" hangingPunct="1" latinLnBrk="0" rtl="0">
-        <a:spcBef>
-          <a:spcPct val="0"/>
-        </a:spcBef>
-        <a:buNone/>
-        <a:defRPr kern="1200" sz="3300">
-          <a:solidFill>
-            <a:schemeClr val="tx1"/>
-          </a:solidFill>
-          <a:latin typeface="+mj-lt"/>
-          <a:ea typeface="+mj-ea"/>
-          <a:cs typeface="+mj-cs"/>
-        </a:defRPr>
-      </a:lvl1pPr>
-    </p:titleStyle>
-    <p:bodyStyle>
-      <a:lvl1pPr algn="l" defTabSz="342900" eaLnBrk="1" hangingPunct="1" indent="-342900" latinLnBrk="0" marL="342900" rtl="0">
-        <a:spcBef>
-          <a:spcPct val="20000"/>
-        </a:spcBef>
-        <a:buFont typeface="Arial"/>
-        <a:buChar char="•"/>
-        <a:defRPr kern="1200" sz="2400">
-          <a:solidFill>
-            <a:schemeClr val="tx1"/>
-          </a:solidFill>
-          <a:latin typeface="+mn-lt"/>
-          <a:ea typeface="+mn-ea"/>
-          <a:cs typeface="+mn-cs"/>
-        </a:defRPr>
-      </a:lvl1pPr>
-      <a:lvl2pPr algn="l" defTabSz="342900" eaLnBrk="1" hangingPunct="1" indent="-342900" latinLnBrk="0" marL="685800" rtl="0">
-        <a:spcBef>
-          <a:spcPct val="20000"/>
-        </a:spcBef>
-        <a:buFont typeface="Arial"/>
-        <a:buChar char="–"/>
-        <a:defRPr kern="1200" sz="2100">
-          <a:solidFill>
-            <a:schemeClr val="tx1"/>
-          </a:solidFill>
-          <a:latin typeface="+mn-lt"/>
-          <a:ea typeface="+mn-ea"/>
-          <a:cs typeface="+mn-cs"/>
-        </a:defRPr>
-      </a:lvl2pPr>
-      <a:lvl3pPr algn="l" defTabSz="342900" eaLnBrk="1" hangingPunct="1" indent="-342900" latinLnBrk="0" marL="1028700" rtl="0">
-        <a:spcBef>
-          <a:spcPct val="20000"/>
-        </a:spcBef>
-        <a:buFont typeface="Arial"/>
-        <a:buChar char="•"/>
-        <a:defRPr kern="1200" sz="1800">
-          <a:solidFill>
-            <a:schemeClr val="tx1"/>
-          </a:solidFill>
-          <a:latin typeface="+mn-lt"/>
-          <a:ea typeface="+mn-ea"/>
-          <a:cs typeface="+mn-cs"/>
-        </a:defRPr>
-      </a:lvl3pPr>
-      <a:lvl4pPr algn="l" defTabSz="342900" eaLnBrk="1" hangingPunct="1" indent="-342900" latinLnBrk="0" marL="1371600" rtl="0">
-        <a:spcBef>
-          <a:spcPct val="20000"/>
-        </a:spcBef>
-        <a:buFont typeface="Arial"/>
-        <a:buChar char="–"/>
-        <a:defRPr kern="1200" sz="1500">
-          <a:solidFill>
-            <a:schemeClr val="tx1"/>
-          </a:solidFill>
-          <a:latin typeface="+mn-lt"/>
-          <a:ea typeface="+mn-ea"/>
-          <a:cs typeface="+mn-cs"/>
-        </a:defRPr>
-      </a:lvl4pPr>
-      <a:lvl5pPr algn="l" defTabSz="342900" eaLnBrk="1" hangingPunct="1" indent="-342900" latinLnBrk="0" marL="1714500" rtl="0">
-        <a:spcBef>
-          <a:spcPct val="20000"/>
-        </a:spcBef>
-        <a:buFont typeface="Arial"/>
-        <a:buChar char="»"/>
-        <a:defRPr kern="1200" sz="1500">
-          <a:solidFill>
-            <a:schemeClr val="tx1"/>
-          </a:solidFill>
-          <a:latin typeface="+mn-lt"/>
-          <a:ea typeface="+mn-ea"/>
-          <a:cs typeface="+mn-cs"/>
-        </a:defRPr>
-      </a:lvl5pPr>
-      <a:lvl6pPr algn="l" defTabSz="342900" eaLnBrk="1" hangingPunct="1" indent="-342900" latinLnBrk="0" marL="2057400" rtl="0">
-        <a:spcBef>
-          <a:spcPct val="20000"/>
-        </a:spcBef>
-        <a:buFont typeface="Arial"/>
-        <a:buChar char="•"/>
-        <a:defRPr kern="1200" sz="1500">
-          <a:solidFill>
-            <a:schemeClr val="tx1"/>
-          </a:solidFill>
-          <a:latin typeface="+mn-lt"/>
-          <a:ea typeface="+mn-ea"/>
-          <a:cs typeface="+mn-cs"/>
-        </a:defRPr>
-      </a:lvl6pPr>
-      <a:lvl7pPr algn="l" defTabSz="342900" eaLnBrk="1" hangingPunct="1" indent="-342900" latinLnBrk="0" marL="2400300" rtl="0">
-        <a:spcBef>
-          <a:spcPct val="20000"/>
-        </a:spcBef>
-        <a:buFont typeface="Arial"/>
-        <a:buChar char="•"/>
-        <a:defRPr kern="1200" sz="1500">
-          <a:solidFill>
-            <a:schemeClr val="tx1"/>
-          </a:solidFill>
-          <a:latin typeface="+mn-lt"/>
-          <a:ea typeface="+mn-ea"/>
-          <a:cs typeface="+mn-cs"/>
-        </a:defRPr>
-      </a:lvl7pPr>
-      <a:lvl8pPr algn="l" defTabSz="342900" eaLnBrk="1" hangingPunct="1" indent="-342900" latinLnBrk="0" marL="2743200" rtl="0">
-        <a:spcBef>
-          <a:spcPct val="20000"/>
-        </a:spcBef>
-        <a:buFont typeface="Arial"/>
-        <a:buChar char="•"/>
-        <a:defRPr kern="1200" sz="1500">
-          <a:solidFill>
-            <a:schemeClr val="tx1"/>
-          </a:solidFill>
-          <a:latin typeface="+mn-lt"/>
-          <a:ea typeface="+mn-ea"/>
-          <a:cs typeface="+mn-cs"/>
-        </a:defRPr>
-      </a:lvl8pPr>
-      <a:lvl9pPr algn="l" defTabSz="342900" eaLnBrk="1" hangingPunct="1" indent="-342900" latinLnBrk="0" marL="3086100" rtl="0">
-        <a:spcBef>
-          <a:spcPct val="20000"/>
-        </a:spcBef>
-        <a:buFont typeface="Arial"/>
-        <a:buChar char="•"/>
-        <a:defRPr kern="1200" sz="1500">
-          <a:solidFill>
-            <a:schemeClr val="tx1"/>
-          </a:solidFill>
-          <a:latin typeface="+mn-lt"/>
-          <a:ea typeface="+mn-ea"/>
-          <a:cs typeface="+mn-cs"/>
-        </a:defRPr>
-      </a:lvl9pPr>
-    </p:bodyStyle>
-    <p:otherStyle>
-      <a:defPPr>
-        <a:defRPr lang="en-US"/>
-      </a:defPPr>
-      <a:lvl1pPr algn="l" defTabSz="342900" eaLnBrk="1" hangingPunct="1" latinLnBrk="0" marL="0" rtl="0">
-        <a:defRPr kern="1200" sz="1350">
-          <a:solidFill>
-            <a:schemeClr val="tx1"/>
-          </a:solidFill>
-          <a:latin typeface="+mn-lt"/>
-          <a:ea typeface="+mn-ea"/>
-          <a:cs typeface="+mn-cs"/>
-        </a:defRPr>
-      </a:lvl1pPr>
-      <a:lvl2pPr algn="l" defTabSz="342900" eaLnBrk="1" hangingPunct="1" latinLnBrk="0" marL="342900" rtl="0">
-        <a:defRPr kern="1200" sz="1350">
-          <a:solidFill>
-            <a:schemeClr val="tx1"/>
-          </a:solidFill>
-          <a:latin typeface="+mn-lt"/>
-          <a:ea typeface="+mn-ea"/>
-          <a:cs typeface="+mn-cs"/>
-        </a:defRPr>
-      </a:lvl2pPr>
-      <a:lvl3pPr algn="l" defTabSz="342900" eaLnBrk="1" hangingPunct="1" latinLnBrk="0" marL="685800" rtl="0">
-        <a:defRPr kern="1200" sz="1350">
-          <a:solidFill>
-            <a:schemeClr val="tx1"/>
-          </a:solidFill>
-          <a:latin typeface="+mn-lt"/>
-          <a:ea typeface="+mn-ea"/>
-          <a:cs typeface="+mn-cs"/>
-        </a:defRPr>
-      </a:lvl3pPr>
-      <a:lvl4pPr algn="l" defTabSz="342900" eaLnBrk="1" hangingPunct="1" latinLnBrk="0" marL="1028700" rtl="0">
-        <a:defRPr kern="1200" sz="1350">
-          <a:solidFill>
-            <a:schemeClr val="tx1"/>
-          </a:solidFill>
-          <a:latin typeface="+mn-lt"/>
-          <a:ea typeface="+mn-ea"/>
-          <a:cs typeface="+mn-cs"/>
-        </a:defRPr>
-      </a:lvl4pPr>
-      <a:lvl5pPr algn="l" defTabSz="342900" eaLnBrk="1" hangingPunct="1" latinLnBrk="0" marL="1371600" rtl="0">
-        <a:defRPr kern="1200" sz="1350">
-          <a:solidFill>
-            <a:schemeClr val="tx1"/>
-          </a:solidFill>
-          <a:latin typeface="+mn-lt"/>
-          <a:ea typeface="+mn-ea"/>
-          <a:cs typeface="+mn-cs"/>
-        </a:defRPr>
-      </a:lvl5pPr>
-      <a:lvl6pPr algn="l" defTabSz="342900" eaLnBrk="1" hangingPunct="1" latinLnBrk="0" marL="1714500" rtl="0">
-        <a:defRPr kern="1200" sz="1350">
-          <a:solidFill>
-            <a:schemeClr val="tx1"/>
-          </a:solidFill>
-          <a:latin typeface="+mn-lt"/>
-          <a:ea typeface="+mn-ea"/>
-          <a:cs typeface="+mn-cs"/>
-        </a:defRPr>
-      </a:lvl6pPr>
-      <a:lvl7pPr algn="l" defTabSz="342900" eaLnBrk="1" hangingPunct="1" latinLnBrk="0" marL="2057400" rtl="0">
-        <a:defRPr kern="1200" sz="1350">
-          <a:solidFill>
-            <a:schemeClr val="tx1"/>
-          </a:solidFill>
-          <a:latin typeface="+mn-lt"/>
-          <a:ea typeface="+mn-ea"/>
-          <a:cs typeface="+mn-cs"/>
-        </a:defRPr>
-      </a:lvl7pPr>
-      <a:lvl8pPr algn="l" defTabSz="342900" eaLnBrk="1" hangingPunct="1" latinLnBrk="0" marL="2400300" rtl="0">
-        <a:defRPr kern="1200" sz="1350">
-          <a:solidFill>
-            <a:schemeClr val="tx1"/>
-          </a:solidFill>
-          <a:latin typeface="+mn-lt"/>
-          <a:ea typeface="+mn-ea"/>
-          <a:cs typeface="+mn-cs"/>
-        </a:defRPr>
-      </a:lvl8pPr>
-      <a:lvl9pPr algn="l" defTabSz="342900" eaLnBrk="1" hangingPunct="1" latinLnBrk="0" marL="2743200" rtl="0">
-        <a:defRPr kern="1200" sz="1350">
-          <a:solidFill>
-            <a:schemeClr val="tx1"/>
-          </a:solidFill>
-          <a:latin typeface="+mn-lt"/>
-          <a:ea typeface="+mn-ea"/>
-          <a:cs typeface="+mn-cs"/>
-        </a:defRPr>
-      </a:lvl9pPr>
-    </p:otherStyle>
+    <p:titleStyle/>
+    <p:bodyStyle/>
+    <p:otherStyle/>
   </p:txStyles>
 </p:sldMaster>
 </file>
@@ -3192,7 +2609,7 @@
           <a:bodyPr/>
           <a:lstStyle/>
           <a:p>
-            <a:pPr lvl="0" indent="-342900" marL="342900">
+            <a:pPr lvl="0">
               <a:buAutoNum type="arabicPeriod"/>
             </a:pPr>
             <a:r>
@@ -3209,7 +2626,7 @@
             </a:r>
           </a:p>
           <a:p>
-            <a:pPr lvl="0" indent="-342900" marL="342900">
+            <a:pPr lvl="0">
               <a:buAutoNum type="arabicPeriod"/>
             </a:pPr>
             <a:r>
@@ -3218,7 +2635,7 @@
             </a:r>
           </a:p>
           <a:p>
-            <a:pPr lvl="0" indent="-342900" marL="342900">
+            <a:pPr lvl="0">
               <a:buAutoNum type="arabicPeriod"/>
             </a:pPr>
             <a:r>
@@ -3227,7 +2644,7 @@
             </a:r>
           </a:p>
           <a:p>
-            <a:pPr lvl="0" indent="-342900" marL="342900">
+            <a:pPr lvl="0">
               <a:buAutoNum type="arabicPeriod"/>
             </a:pPr>
             <a:r>
@@ -5678,7 +5095,7 @@
           <a:bodyPr/>
           <a:lstStyle/>
           <a:p>
-            <a:pPr lvl="0" indent="-342900" marL="342900">
+            <a:pPr lvl="0">
               <a:buAutoNum type="arabicPeriod"/>
             </a:pPr>
             <a:r>
@@ -5697,7 +5114,7 @@
             </a:r>
           </a:p>
           <a:p>
-            <a:pPr lvl="0" indent="-342900" marL="342900">
+            <a:pPr lvl="0">
               <a:buAutoNum type="arabicPeriod"/>
             </a:pPr>
             <a:r>
@@ -5716,7 +5133,7 @@
             </a:r>
           </a:p>
           <a:p>
-            <a:pPr lvl="0" indent="-342900" marL="342900">
+            <a:pPr lvl="0">
               <a:buAutoNum type="arabicPeriod"/>
             </a:pPr>
             <a:r>
@@ -5735,7 +5152,7 @@
             </a:r>
           </a:p>
           <a:p>
-            <a:pPr lvl="0" indent="-342900" marL="342900">
+            <a:pPr lvl="0">
               <a:buAutoNum type="arabicPeriod"/>
             </a:pPr>
             <a:r>
@@ -5754,7 +5171,7 @@
             </a:r>
           </a:p>
           <a:p>
-            <a:pPr lvl="0" indent="-342900" marL="342900">
+            <a:pPr lvl="0">
               <a:buAutoNum type="arabicPeriod"/>
             </a:pPr>
             <a:r>
@@ -5783,7 +5200,7 @@
             </a:r>
           </a:p>
           <a:p>
-            <a:pPr lvl="0" indent="-342900" marL="342900">
+            <a:pPr lvl="0">
               <a:buAutoNum type="arabicPeriod"/>
             </a:pPr>
             <a:r>
@@ -5802,7 +5219,7 @@
             </a:r>
           </a:p>
           <a:p>
-            <a:pPr lvl="0" indent="-342900" marL="342900">
+            <a:pPr lvl="0">
               <a:buAutoNum type="arabicPeriod"/>
             </a:pPr>
             <a:r>
@@ -5831,7 +5248,7 @@
             </a:r>
           </a:p>
           <a:p>
-            <a:pPr lvl="0" indent="-342900" marL="342900">
+            <a:pPr lvl="0">
               <a:buAutoNum type="arabicPeriod"/>
             </a:pPr>
             <a:r>
@@ -5850,7 +5267,7 @@
             </a:r>
           </a:p>
           <a:p>
-            <a:pPr lvl="0" indent="-342900" marL="342900">
+            <a:pPr lvl="0">
               <a:buAutoNum type="arabicPeriod"/>
             </a:pPr>
             <a:r>
@@ -5869,7 +5286,7 @@
             </a:r>
           </a:p>
           <a:p>
-            <a:pPr lvl="0" indent="-342900" marL="342900">
+            <a:pPr lvl="0">
               <a:buAutoNum type="arabicPeriod"/>
             </a:pPr>
             <a:r>
@@ -5878,7 +5295,7 @@
             </a:r>
           </a:p>
           <a:p>
-            <a:pPr lvl="0" indent="-342900" marL="342900">
+            <a:pPr lvl="0">
               <a:buAutoNum type="arabicPeriod"/>
             </a:pPr>
             <a:r>
@@ -5887,7 +5304,7 @@
             </a:r>
           </a:p>
           <a:p>
-            <a:pPr lvl="0" indent="-342900" marL="342900">
+            <a:pPr lvl="0">
               <a:buAutoNum type="arabicPeriod"/>
             </a:pPr>
             <a:r>
@@ -5922,322 +5339,79 @@
 </file>
 
 <file path=ppt/theme/theme1.xml><?xml version="1.0" encoding="utf-8"?>
-<a:theme xmlns:a="http://schemas.openxmlformats.org/drawingml/2006/main" name="Office Theme">
+<a:theme xmlns:a="http://schemas.openxmlformats.org/drawingml/2006/main" name="OpenERP">
   <a:themeElements>
-    <a:clrScheme name="Office">
+    <a:clrScheme name="OpenERP">
       <a:dk1>
-        <a:sysClr val="windowText" lastClr="000000"/>
+        <a:srgbClr val="172033"/>
       </a:dk1>
       <a:lt1>
-        <a:sysClr val="window" lastClr="FFFFFF"/>
+        <a:srgbClr val="FFFFFF"/>
       </a:lt1>
       <a:dk2>
-        <a:srgbClr val="1F497D"/>
+        <a:srgbClr val="334155"/>
       </a:dk2>
       <a:lt2>
-        <a:srgbClr val="EEECE1"/>
+        <a:srgbClr val="F7F9FC"/>
       </a:lt2>
       <a:accent1>
-        <a:srgbClr val="4F81BD"/>
+        <a:srgbClr val="0F9F9A"/>
       </a:accent1>
       <a:accent2>
-        <a:srgbClr val="C0504D"/>
+        <a:srgbClr val="2563EB"/>
       </a:accent2>
       <a:accent3>
-        <a:srgbClr val="9BBB59"/>
+        <a:srgbClr val="1E9B57"/>
       </a:accent3>
       <a:accent4>
-        <a:srgbClr val="8064A2"/>
+        <a:srgbClr val="D89000"/>
       </a:accent4>
       <a:accent5>
-        <a:srgbClr val="4BACC6"/>
+        <a:srgbClr val="6D5BD0"/>
       </a:accent5>
       <a:accent6>
-        <a:srgbClr val="F79646"/>
+        <a:srgbClr val="C2413B"/>
       </a:accent6>
       <a:hlink>
-        <a:srgbClr val="0000FF"/>
+        <a:srgbClr val="2563EB"/>
       </a:hlink>
       <a:folHlink>
-        <a:srgbClr val="800080"/>
+        <a:srgbClr val="6D5BD0"/>
       </a:folHlink>
     </a:clrScheme>
-    <a:fontScheme name="Office">
+    <a:fontScheme name="OpenERP">
       <a:majorFont>
-        <a:latin typeface="Calibri"/>
-        <a:ea typeface=""/>
-        <a:cs typeface=""/>
-        <a:font script="Jpan" typeface="ＭＳ Ｐゴシック"/>
-        <a:font script="Hang" typeface="맑은 고딕"/>
-        <a:font script="Hans" typeface="宋体"/>
-        <a:font script="Hant" typeface="新細明體"/>
-        <a:font script="Arab" typeface="Times New Roman"/>
-        <a:font script="Hebr" typeface="Times New Roman"/>
-        <a:font script="Thai" typeface="Angsana New"/>
-        <a:font script="Ethi" typeface="Nyala"/>
-        <a:font script="Beng" typeface="Vrinda"/>
-        <a:font script="Gujr" typeface="Shruti"/>
-        <a:font script="Khmr" typeface="MoolBoran"/>
-        <a:font script="Knda" typeface="Tunga"/>
-        <a:font script="Guru" typeface="Raavi"/>
-        <a:font script="Cans" typeface="Euphemia"/>
-        <a:font script="Cher" typeface="Plantagenet Cherokee"/>
-        <a:font script="Yiii" typeface="Microsoft Yi Baiti"/>
-        <a:font script="Tibt" typeface="Microsoft Himalaya"/>
-        <a:font script="Thaa" typeface="MV Boli"/>
-        <a:font script="Deva" typeface="Mangal"/>
-        <a:font script="Telu" typeface="Gautami"/>
-        <a:font script="Taml" typeface="Latha"/>
-        <a:font script="Syrc" typeface="Estrangelo Edessa"/>
-        <a:font script="Orya" typeface="Kalinga"/>
-        <a:font script="Mlym" typeface="Kartika"/>
-        <a:font script="Laoo" typeface="DokChampa"/>
-        <a:font script="Sinh" typeface="Iskoola Pota"/>
-        <a:font script="Mong" typeface="Mongolian Baiti"/>
-        <a:font script="Viet" typeface="Times New Roman"/>
-        <a:font script="Uigh" typeface="Microsoft Uighur"/>
-        <a:font script="Geor" typeface="Sylfaen"/>
+        <a:latin typeface="DejaVu Sans"/>
       </a:majorFont>
       <a:minorFont>
-        <a:latin typeface="Calibri"/>
-        <a:ea typeface=""/>
-        <a:cs typeface=""/>
-        <a:font script="Jpan" typeface="ＭＳ Ｐゴシック"/>
-        <a:font script="Hang" typeface="맑은 고딕"/>
-        <a:font script="Hans" typeface="宋体"/>
-        <a:font script="Hant" typeface="新細明體"/>
-        <a:font script="Arab" typeface="Arial"/>
-        <a:font script="Hebr" typeface="Arial"/>
-        <a:font script="Thai" typeface="Cordia New"/>
-        <a:font script="Ethi" typeface="Nyala"/>
-        <a:font script="Beng" typeface="Vrinda"/>
-        <a:font script="Gujr" typeface="Shruti"/>
-        <a:font script="Khmr" typeface="DaunPenh"/>
-        <a:font script="Knda" typeface="Tunga"/>
-        <a:font script="Guru" typeface="Raavi"/>
-        <a:font script="Cans" typeface="Euphemia"/>
-        <a:font script="Cher" typeface="Plantagenet Cherokee"/>
-        <a:font script="Yiii" typeface="Microsoft Yi Baiti"/>
-        <a:font script="Tibt" typeface="Microsoft Himalaya"/>
-        <a:font script="Thaa" typeface="MV Boli"/>
-        <a:font script="Deva" typeface="Mangal"/>
-        <a:font script="Telu" typeface="Gautami"/>
-        <a:font script="Taml" typeface="Latha"/>
-        <a:font script="Syrc" typeface="Estrangelo Edessa"/>
-        <a:font script="Orya" typeface="Kalinga"/>
-        <a:font script="Mlym" typeface="Kartika"/>
-        <a:font script="Laoo" typeface="DokChampa"/>
-        <a:font script="Sinh" typeface="Iskoola Pota"/>
-        <a:font script="Mong" typeface="Mongolian Baiti"/>
-        <a:font script="Viet" typeface="Arial"/>
-        <a:font script="Uigh" typeface="Microsoft Uighur"/>
-        <a:font script="Geor" typeface="Sylfaen"/>
+        <a:latin typeface="DejaVu Sans"/>
       </a:minorFont>
     </a:fontScheme>
-    <a:fmtScheme name="Office">
+    <a:fmtScheme name="OpenERP">
       <a:fillStyleLst>
         <a:solidFill>
           <a:schemeClr val="phClr"/>
         </a:solidFill>
-        <a:gradFill rotWithShape="1">
-          <a:gsLst>
-            <a:gs pos="0">
-              <a:schemeClr val="phClr">
-                <a:tint val="50000"/>
-                <a:satMod val="300000"/>
-              </a:schemeClr>
-            </a:gs>
-            <a:gs pos="35000">
-              <a:schemeClr val="phClr">
-                <a:tint val="37000"/>
-                <a:satMod val="300000"/>
-              </a:schemeClr>
-            </a:gs>
-            <a:gs pos="100000">
-              <a:schemeClr val="phClr">
-                <a:tint val="15000"/>
-                <a:satMod val="350000"/>
-              </a:schemeClr>
-            </a:gs>
-          </a:gsLst>
-          <a:lin ang="16200000" scaled="1"/>
-        </a:gradFill>
-        <a:gradFill rotWithShape="1">
-          <a:gsLst>
-            <a:gs pos="0">
-              <a:schemeClr val="phClr">
-                <a:tint val="100000"/>
-                <a:shade val="100000"/>
-                <a:satMod val="130000"/>
-              </a:schemeClr>
-            </a:gs>
-            <a:gs pos="100000">
-              <a:schemeClr val="phClr">
-                <a:tint val="50000"/>
-                <a:shade val="100000"/>
-                <a:satMod val="350000"/>
-              </a:schemeClr>
-            </a:gs>
-          </a:gsLst>
-          <a:lin ang="16200000" scaled="0"/>
-        </a:gradFill>
       </a:fillStyleLst>
       <a:lnStyleLst>
-        <a:ln w="9525" cap="flat" cmpd="sng" algn="ctr">
-          <a:solidFill>
-            <a:schemeClr val="phClr">
-              <a:shade val="95000"/>
-              <a:satMod val="105000"/>
-            </a:schemeClr>
-          </a:solidFill>
-          <a:prstDash val="solid"/>
-        </a:ln>
-        <a:ln w="25400" cap="flat" cmpd="sng" algn="ctr">
+        <a:ln w="9525">
           <a:solidFill>
             <a:schemeClr val="phClr"/>
           </a:solidFill>
-          <a:prstDash val="solid"/>
-        </a:ln>
-        <a:ln w="38100" cap="flat" cmpd="sng" algn="ctr">
-          <a:solidFill>
-            <a:schemeClr val="phClr"/>
-          </a:solidFill>
-          <a:prstDash val="solid"/>
         </a:ln>
       </a:lnStyleLst>
       <a:effectStyleLst>
         <a:effectStyle>
-          <a:effectLst>
-            <a:outerShdw blurRad="40000" dist="20000" dir="5400000" rotWithShape="0">
-              <a:srgbClr val="000000">
-                <a:alpha val="38000"/>
-              </a:srgbClr>
-            </a:outerShdw>
-          </a:effectLst>
-        </a:effectStyle>
-        <a:effectStyle>
-          <a:effectLst>
-            <a:outerShdw blurRad="40000" dist="23000" dir="5400000" rotWithShape="0">
-              <a:srgbClr val="000000">
-                <a:alpha val="35000"/>
-              </a:srgbClr>
-            </a:outerShdw>
-          </a:effectLst>
-        </a:effectStyle>
-        <a:effectStyle>
-          <a:effectLst>
-            <a:outerShdw blurRad="40000" dist="23000" dir="5400000" rotWithShape="0">
-              <a:srgbClr val="000000">
-                <a:alpha val="35000"/>
-              </a:srgbClr>
-            </a:outerShdw>
-          </a:effectLst>
-          <a:scene3d>
-            <a:camera prst="orthographicFront">
-              <a:rot lat="0" lon="0" rev="0"/>
-            </a:camera>
-            <a:lightRig rig="threePt" dir="t">
-              <a:rot lat="0" lon="0" rev="1200000"/>
-            </a:lightRig>
-          </a:scene3d>
-          <a:sp3d>
-            <a:bevelT w="63500" h="25400"/>
-          </a:sp3d>
+          <a:effectLst/>
         </a:effectStyle>
       </a:effectStyleLst>
       <a:bgFillStyleLst>
         <a:solidFill>
           <a:schemeClr val="phClr"/>
         </a:solidFill>
-        <a:gradFill rotWithShape="1">
-          <a:gsLst>
-            <a:gs pos="0">
-              <a:schemeClr val="phClr">
-                <a:tint val="40000"/>
-                <a:satMod val="350000"/>
-              </a:schemeClr>
-            </a:gs>
-            <a:gs pos="40000">
-              <a:schemeClr val="phClr">
-                <a:tint val="45000"/>
-                <a:shade val="99000"/>
-                <a:satMod val="350000"/>
-              </a:schemeClr>
-            </a:gs>
-            <a:gs pos="100000">
-              <a:schemeClr val="phClr">
-                <a:shade val="20000"/>
-                <a:satMod val="255000"/>
-              </a:schemeClr>
-            </a:gs>
-          </a:gsLst>
-          <a:path path="circle">
-            <a:fillToRect l="50000" t="-80000" r="50000" b="180000"/>
-          </a:path>
-        </a:gradFill>
-        <a:gradFill rotWithShape="1">
-          <a:gsLst>
-            <a:gs pos="0">
-              <a:schemeClr val="phClr">
-                <a:tint val="80000"/>
-                <a:satMod val="300000"/>
-              </a:schemeClr>
-            </a:gs>
-            <a:gs pos="100000">
-              <a:schemeClr val="phClr">
-                <a:shade val="30000"/>
-                <a:satMod val="200000"/>
-              </a:schemeClr>
-            </a:gs>
-          </a:gsLst>
-          <a:path path="circle">
-            <a:fillToRect l="50000" t="50000" r="50000" b="50000"/>
-          </a:path>
-        </a:gradFill>
       </a:bgFillStyleLst>
     </a:fmtScheme>
   </a:themeElements>
-  <a:objectDefaults>
-    <a:spDef>
-      <a:spPr/>
-      <a:bodyPr/>
-      <a:lstStyle/>
-      <a:style>
-        <a:lnRef idx="1">
-          <a:schemeClr val="accent1"/>
-        </a:lnRef>
-        <a:fillRef idx="3">
-          <a:schemeClr val="accent1"/>
-        </a:fillRef>
-        <a:effectRef idx="2">
-          <a:schemeClr val="accent1"/>
-        </a:effectRef>
-        <a:fontRef idx="minor">
-          <a:schemeClr val="lt1"/>
-        </a:fontRef>
-      </a:style>
-    </a:spDef>
-    <a:lnDef>
-      <a:spPr/>
-      <a:bodyPr/>
-      <a:lstStyle/>
-      <a:style>
-        <a:lnRef idx="2">
-          <a:schemeClr val="accent1"/>
-        </a:lnRef>
-        <a:fillRef idx="0">
-          <a:schemeClr val="accent1"/>
-        </a:fillRef>
-        <a:effectRef idx="1">
-          <a:schemeClr val="accent1"/>
-        </a:effectRef>
-        <a:fontRef idx="minor">
-          <a:schemeClr val="tx1"/>
-        </a:fontRef>
-      </a:style>
-    </a:lnDef>
-  </a:objectDefaults>
-  <a:extraClrSchemeLst/>
 </a:theme>
 </file>
 

</xml_diff>

<commit_message>
Sync Progress sections in MVP specs and design doc
</commit_message>
<xml_diff>
--- a/docs/study/10-mvp-specs/decision-pack.pptx
+++ b/docs/study/10-mvp-specs/decision-pack.pptx
@@ -2851,17 +2851,7 @@
             </a:r>
             <a:r>
               <a:rPr/>
-              <a:t> : 6 specs MVP enrichies (</a:t>
-            </a:r>
-            <a:r>
-              <a:rPr>
-                <a:latin typeface="Courier"/>
-              </a:rPr>
-              <a:t>docs/study/10-mvp-specs/</a:t>
-            </a:r>
-            <a:r>
-              <a:rPr/>
-              <a:t>), commit </a:t>
+              <a:t> : 6 specs MVP enrichies (commit </a:t>
             </a:r>
             <a:r>
               <a:rPr>
@@ -2871,7 +2861,7 @@
             </a:r>
             <a:r>
               <a:rPr/>
-              <a:t>, +1675 lignes. Double revue (</a:t>
+              <a:t>, +1675 lignes), double revue (</a:t>
             </a:r>
             <a:r>
               <a:rPr>
@@ -2881,7 +2871,7 @@
             </a:r>
             <a:r>
               <a:rPr/>
-              <a:t> ~5300 mots, </a:t>
+              <a:t> 5300 mots + </a:t>
             </a:r>
             <a:r>
               <a:rPr>
@@ -2891,7 +2881,67 @@
             </a:r>
             <a:r>
               <a:rPr/>
-              <a:t> ~1500 mots).</a:t>
+              <a:t> 1500 mots), decision-pack MD + PPTX (commits </a:t>
+            </a:r>
+            <a:r>
+              <a:rPr>
+                <a:latin typeface="Courier"/>
+              </a:rPr>
+              <a:t>c277be1</a:t>
+            </a:r>
+            <a:r>
+              <a:rPr/>
+              <a:t> + </a:t>
+            </a:r>
+            <a:r>
+              <a:rPr>
+                <a:latin typeface="Courier"/>
+              </a:rPr>
+              <a:t>a499fd2</a:t>
+            </a:r>
+            <a:r>
+              <a:rPr/>
+              <a:t> thème projet), sweep rename </a:t>
+            </a:r>
+            <a:r>
+              <a:rPr>
+                <a:latin typeface="Courier"/>
+              </a:rPr>
+              <a:t>@entropiq</a:t>
+            </a:r>
+            <a:r>
+              <a:rPr/>
+              <a:t> → </a:t>
+            </a:r>
+            <a:r>
+              <a:rPr>
+                <a:latin typeface="Courier"/>
+              </a:rPr>
+              <a:t>@sentropic</a:t>
+            </a:r>
+            <a:r>
+              <a:rPr/>
+              <a:t> plain MIT sur 30 docs (commit </a:t>
+            </a:r>
+            <a:r>
+              <a:rPr>
+                <a:latin typeface="Courier"/>
+              </a:rPr>
+              <a:t>54dede9</a:t>
+            </a:r>
+            <a:r>
+              <a:rPr/>
+              <a:t>, 163 occurrences). Blocs </a:t>
+            </a:r>
+            <a:r>
+              <a:rPr>
+                <a:latin typeface="Courier"/>
+              </a:rPr>
+              <a:t>## Progress</a:t>
+            </a:r>
+            <a:r>
+              <a:rPr/>
+              <a:t> des 6 specs synchronisés.</a:t>
             </a:r>
           </a:p>
           <a:p>
@@ -2902,27 +2952,17 @@
             </a:r>
             <a:r>
               <a:rPr/>
-              <a:t> : arbitrage porteur produit sur ce pack, gravage des décisions inline dans les 6 specs, sweep rename </a:t>
-            </a:r>
-            <a:r>
-              <a:rPr>
-                <a:latin typeface="Courier"/>
-              </a:rPr>
-              <a:t>@entropiq</a:t>
-            </a:r>
-            <a:r>
-              <a:rPr/>
-              <a:t> → </a:t>
-            </a:r>
-            <a:r>
-              <a:rPr>
-                <a:latin typeface="Courier"/>
-              </a:rPr>
-              <a:t>@sentropic</a:t>
-            </a:r>
-            <a:r>
-              <a:rPr/>
-              <a:t> (31 docs).</a:t>
+              <a:t> : arbitrage porteur produit sur ce pack (6 décisions P0 bloquent code), gravage des décisions inline dans les 6 specs, création </a:t>
+            </a:r>
+            <a:r>
+              <a:rPr>
+                <a:latin typeface="Courier"/>
+              </a:rPr>
+              <a:t>NOTICE</a:t>
+            </a:r>
+            <a:r>
+              <a:rPr/>
+              <a:t> racine, script CI anti-copy.</a:t>
             </a:r>
           </a:p>
           <a:p>
@@ -2933,7 +2973,7 @@
             </a:r>
             <a:r>
               <a:rPr/>
-              <a:t> : tu arbitres ; je grave ; je passe en mode réalisation/audit.</a:t>
+              <a:t> : tu arbitres ; je grave ; je passe en mode réalisation/audit. Push remote en attente de ton OK explicite.</a:t>
             </a:r>
           </a:p>
         </p:txBody>

</xml_diff>

<commit_message>
Fix decision-pack PPTX rendering (drop empty reference master)
</commit_message>
<xml_diff>
--- a/docs/study/10-mvp-specs/decision-pack.pptx
+++ b/docs/study/10-mvp-specs/decision-pack.pptx
@@ -1,6 +1,6 @@
 
 <file path=ppt/presentation.xml><?xml version="1.0" encoding="utf-8"?>
-<p:presentation xmlns:a="http://schemas.openxmlformats.org/drawingml/2006/main" xmlns:p="http://schemas.openxmlformats.org/presentationml/2006/main" xmlns:r="http://schemas.openxmlformats.org/officeDocument/2006/relationships">
+<p:presentation xmlns:a="http://schemas.openxmlformats.org/drawingml/2006/main" xmlns:p="http://schemas.openxmlformats.org/presentationml/2006/main" xmlns:r="http://schemas.openxmlformats.org/officeDocument/2006/relationships" autoCompressPictures="0" saveSubsetFonts="1">
   <p:sldMasterIdLst>
     <p:sldMasterId id="2147483648" r:id="rId1"/>
   </p:sldMasterIdLst>
@@ -17,8 +17,119 @@
     <p:sldId id="265" r:id="rId11"/>
     <p:sldId id="266" r:id="rId12"/>
   </p:sldIdLst>
-  <p:sldSz cx="12192000" cy="6858000" type="wide"/>
+  <p:sldSz cx="9144000" cy="5143500" type="screen16x9"/>
   <p:notesSz cx="6858000" cy="9144000"/>
+  <p:defaultTextStyle>
+    <a:defPPr>
+      <a:defRPr lang="en-US"/>
+    </a:defPPr>
+    <a:lvl1pPr algn="l" defTabSz="457200" eaLnBrk="1" hangingPunct="1" latinLnBrk="0" marL="0" rtl="0">
+      <a:defRPr kern="1200" sz="1800">
+        <a:solidFill>
+          <a:schemeClr val="tx1"/>
+        </a:solidFill>
+        <a:latin typeface="+mn-lt"/>
+        <a:ea typeface="+mn-ea"/>
+        <a:cs typeface="+mn-cs"/>
+      </a:defRPr>
+    </a:lvl1pPr>
+    <a:lvl2pPr algn="l" defTabSz="457200" eaLnBrk="1" hangingPunct="1" latinLnBrk="0" marL="457200" rtl="0">
+      <a:defRPr kern="1200" sz="1800">
+        <a:solidFill>
+          <a:schemeClr val="tx1"/>
+        </a:solidFill>
+        <a:latin typeface="+mn-lt"/>
+        <a:ea typeface="+mn-ea"/>
+        <a:cs typeface="+mn-cs"/>
+      </a:defRPr>
+    </a:lvl2pPr>
+    <a:lvl3pPr algn="l" defTabSz="457200" eaLnBrk="1" hangingPunct="1" latinLnBrk="0" marL="914400" rtl="0">
+      <a:defRPr kern="1200" sz="1800">
+        <a:solidFill>
+          <a:schemeClr val="tx1"/>
+        </a:solidFill>
+        <a:latin typeface="+mn-lt"/>
+        <a:ea typeface="+mn-ea"/>
+        <a:cs typeface="+mn-cs"/>
+      </a:defRPr>
+    </a:lvl3pPr>
+    <a:lvl4pPr algn="l" defTabSz="457200" eaLnBrk="1" hangingPunct="1" latinLnBrk="0" marL="1371600" rtl="0">
+      <a:defRPr kern="1200" sz="1800">
+        <a:solidFill>
+          <a:schemeClr val="tx1"/>
+        </a:solidFill>
+        <a:latin typeface="+mn-lt"/>
+        <a:ea typeface="+mn-ea"/>
+        <a:cs typeface="+mn-cs"/>
+      </a:defRPr>
+    </a:lvl4pPr>
+    <a:lvl5pPr algn="l" defTabSz="457200" eaLnBrk="1" hangingPunct="1" latinLnBrk="0" marL="1828800" rtl="0">
+      <a:defRPr kern="1200" sz="1800">
+        <a:solidFill>
+          <a:schemeClr val="tx1"/>
+        </a:solidFill>
+        <a:latin typeface="+mn-lt"/>
+        <a:ea typeface="+mn-ea"/>
+        <a:cs typeface="+mn-cs"/>
+      </a:defRPr>
+    </a:lvl5pPr>
+    <a:lvl6pPr algn="l" defTabSz="457200" eaLnBrk="1" hangingPunct="1" latinLnBrk="0" marL="2286000" rtl="0">
+      <a:defRPr kern="1200" sz="1800">
+        <a:solidFill>
+          <a:schemeClr val="tx1"/>
+        </a:solidFill>
+        <a:latin typeface="+mn-lt"/>
+        <a:ea typeface="+mn-ea"/>
+        <a:cs typeface="+mn-cs"/>
+      </a:defRPr>
+    </a:lvl6pPr>
+    <a:lvl7pPr algn="l" defTabSz="457200" eaLnBrk="1" hangingPunct="1" latinLnBrk="0" marL="2743200" rtl="0">
+      <a:defRPr kern="1200" sz="1800">
+        <a:solidFill>
+          <a:schemeClr val="tx1"/>
+        </a:solidFill>
+        <a:latin typeface="+mn-lt"/>
+        <a:ea typeface="+mn-ea"/>
+        <a:cs typeface="+mn-cs"/>
+      </a:defRPr>
+    </a:lvl7pPr>
+    <a:lvl8pPr algn="l" defTabSz="457200" eaLnBrk="1" hangingPunct="1" latinLnBrk="0" marL="3200400" rtl="0">
+      <a:defRPr kern="1200" sz="1800">
+        <a:solidFill>
+          <a:schemeClr val="tx1"/>
+        </a:solidFill>
+        <a:latin typeface="+mn-lt"/>
+        <a:ea typeface="+mn-ea"/>
+        <a:cs typeface="+mn-cs"/>
+      </a:defRPr>
+    </a:lvl8pPr>
+    <a:lvl9pPr algn="l" defTabSz="457200" eaLnBrk="1" hangingPunct="1" latinLnBrk="0" marL="3657600" rtl="0">
+      <a:defRPr kern="1200" sz="1800">
+        <a:solidFill>
+          <a:schemeClr val="tx1"/>
+        </a:solidFill>
+        <a:latin typeface="+mn-lt"/>
+        <a:ea typeface="+mn-ea"/>
+        <a:cs typeface="+mn-cs"/>
+      </a:defRPr>
+    </a:lvl9pPr>
+  </p:defaultTextStyle>
+  <p:extLst>
+    <p:ext uri="{EFAFB233-063F-42B5-8137-9DF3F51BA10A}">
+      <p15:sldGuideLst xmlns:p15="http://schemas.microsoft.com/office/powerpoint/2012/main">
+        <p15:guide id="1" orient="horz" pos="1620" userDrawn="1">
+          <p15:clr>
+            <a:srgbClr val="A4A3A4"/>
+          </p15:clr>
+        </p15:guide>
+        <p15:guide id="2" pos="2880" userDrawn="1">
+          <p15:clr>
+            <a:srgbClr val="A4A3A4"/>
+          </p15:clr>
+        </p15:guide>
+      </p15:sldGuideLst>
+    </p:ext>
+  </p:extLst>
 </p:presentation>
 </file>
 
@@ -2467,6 +2578,11 @@
 <file path=ppt/slideMasters/slideMaster1.xml><?xml version="1.0" encoding="utf-8"?>
 <p:sldMaster xmlns:a="http://schemas.openxmlformats.org/drawingml/2006/main" xmlns:p="http://schemas.openxmlformats.org/presentationml/2006/main" xmlns:r="http://schemas.openxmlformats.org/officeDocument/2006/relationships">
   <p:cSld>
+    <p:bg>
+      <p:bgRef idx="1001">
+        <a:schemeClr val="bg1"/>
+      </p:bgRef>
+    </p:bg>
     <p:spTree>
       <p:nvGrpSpPr>
         <p:cNvPr id="1" name=""/>
@@ -2481,21 +2597,488 @@
           <a:chExt cx="0" cy="0"/>
         </a:xfrm>
       </p:grpSpPr>
+      <p:sp>
+        <p:nvSpPr>
+          <p:cNvPr id="2" name="Title Placeholder 1"/>
+          <p:cNvSpPr>
+            <a:spLocks noGrp="1"/>
+          </p:cNvSpPr>
+          <p:nvPr>
+            <p:ph type="title"/>
+          </p:nvPr>
+        </p:nvSpPr>
+        <p:spPr>
+          <a:xfrm>
+            <a:off x="457200" y="205979"/>
+            <a:ext cx="8229600" cy="857250"/>
+          </a:xfrm>
+          <a:prstGeom prst="rect">
+            <a:avLst/>
+          </a:prstGeom>
+        </p:spPr>
+        <p:txBody>
+          <a:bodyPr anchor="ctr" bIns="45720" lIns="91440" rIns="91440" rtlCol="0" tIns="45720" vert="horz">
+            <a:normAutofit/>
+          </a:bodyPr>
+          <a:lstStyle/>
+          <a:p>
+            <a:r>
+              <a:rPr lang="en-US"/>
+              <a:t>Click to edit Master title style</a:t>
+            </a:r>
+          </a:p>
+        </p:txBody>
+      </p:sp>
+      <p:sp>
+        <p:nvSpPr>
+          <p:cNvPr id="3" name="Text Placeholder 2"/>
+          <p:cNvSpPr>
+            <a:spLocks noGrp="1"/>
+          </p:cNvSpPr>
+          <p:nvPr>
+            <p:ph idx="1" type="body"/>
+          </p:nvPr>
+        </p:nvSpPr>
+        <p:spPr>
+          <a:xfrm>
+            <a:off x="457200" y="1200151"/>
+            <a:ext cx="8229600" cy="3394472"/>
+          </a:xfrm>
+          <a:prstGeom prst="rect">
+            <a:avLst/>
+          </a:prstGeom>
+        </p:spPr>
+        <p:txBody>
+          <a:bodyPr bIns="45720" lIns="91440" rIns="91440" rtlCol="0" tIns="45720" vert="horz">
+            <a:normAutofit/>
+          </a:bodyPr>
+          <a:lstStyle/>
+          <a:p>
+            <a:pPr lvl="0"/>
+            <a:r>
+              <a:rPr lang="en-US"/>
+              <a:t>Click to edit Master text styles</a:t>
+            </a:r>
+          </a:p>
+          <a:p>
+            <a:pPr lvl="1"/>
+            <a:r>
+              <a:rPr lang="en-US"/>
+              <a:t>Second level</a:t>
+            </a:r>
+          </a:p>
+          <a:p>
+            <a:pPr lvl="2"/>
+            <a:r>
+              <a:rPr lang="en-US"/>
+              <a:t>Third level</a:t>
+            </a:r>
+          </a:p>
+          <a:p>
+            <a:pPr lvl="3"/>
+            <a:r>
+              <a:rPr lang="en-US"/>
+              <a:t>Fourth level</a:t>
+            </a:r>
+          </a:p>
+          <a:p>
+            <a:pPr lvl="4"/>
+            <a:r>
+              <a:rPr lang="en-US"/>
+              <a:t>Fifth level</a:t>
+            </a:r>
+          </a:p>
+        </p:txBody>
+      </p:sp>
+      <p:sp>
+        <p:nvSpPr>
+          <p:cNvPr id="4" name="Date Placeholder 3"/>
+          <p:cNvSpPr>
+            <a:spLocks noGrp="1"/>
+          </p:cNvSpPr>
+          <p:nvPr>
+            <p:ph idx="2" sz="half" type="dt"/>
+          </p:nvPr>
+        </p:nvSpPr>
+        <p:spPr>
+          <a:xfrm>
+            <a:off x="457200" y="4767263"/>
+            <a:ext cx="2133600" cy="273844"/>
+          </a:xfrm>
+          <a:prstGeom prst="rect">
+            <a:avLst/>
+          </a:prstGeom>
+        </p:spPr>
+        <p:txBody>
+          <a:bodyPr anchor="ctr" bIns="45720" lIns="91440" rIns="91440" rtlCol="0" tIns="45720" vert="horz"/>
+          <a:lstStyle>
+            <a:lvl1pPr algn="l">
+              <a:defRPr sz="900">
+                <a:solidFill>
+                  <a:schemeClr val="tx1">
+                    <a:tint val="75000"/>
+                  </a:schemeClr>
+                </a:solidFill>
+              </a:defRPr>
+            </a:lvl1pPr>
+          </a:lstStyle>
+          <a:p>
+            <a:fld id="{241EB5C9-1307-BA42-ABA2-0BC069CD8E7F}" type="datetimeFigureOut">
+              <a:rPr lang="en-US" smtClean="0"/>
+              <a:t>1/2/22</a:t>
+            </a:fld>
+            <a:endParaRPr lang="en-US"/>
+          </a:p>
+        </p:txBody>
+      </p:sp>
+      <p:sp>
+        <p:nvSpPr>
+          <p:cNvPr id="5" name="Footer Placeholder 4"/>
+          <p:cNvSpPr>
+            <a:spLocks noGrp="1"/>
+          </p:cNvSpPr>
+          <p:nvPr>
+            <p:ph idx="3" sz="quarter" type="ftr"/>
+          </p:nvPr>
+        </p:nvSpPr>
+        <p:spPr>
+          <a:xfrm>
+            <a:off x="3124200" y="4767263"/>
+            <a:ext cx="2895600" cy="273844"/>
+          </a:xfrm>
+          <a:prstGeom prst="rect">
+            <a:avLst/>
+          </a:prstGeom>
+        </p:spPr>
+        <p:txBody>
+          <a:bodyPr anchor="ctr" bIns="45720" lIns="91440" rIns="91440" rtlCol="0" tIns="45720" vert="horz"/>
+          <a:lstStyle>
+            <a:lvl1pPr algn="ctr">
+              <a:defRPr sz="900">
+                <a:solidFill>
+                  <a:schemeClr val="tx1">
+                    <a:tint val="75000"/>
+                  </a:schemeClr>
+                </a:solidFill>
+              </a:defRPr>
+            </a:lvl1pPr>
+          </a:lstStyle>
+          <a:p>
+            <a:endParaRPr lang="en-US"/>
+          </a:p>
+        </p:txBody>
+      </p:sp>
+      <p:sp>
+        <p:nvSpPr>
+          <p:cNvPr id="6" name="Slide Number Placeholder 5"/>
+          <p:cNvSpPr>
+            <a:spLocks noGrp="1"/>
+          </p:cNvSpPr>
+          <p:nvPr>
+            <p:ph idx="4" sz="quarter" type="sldNum"/>
+          </p:nvPr>
+        </p:nvSpPr>
+        <p:spPr>
+          <a:xfrm>
+            <a:off x="6553200" y="4767263"/>
+            <a:ext cx="2133600" cy="273844"/>
+          </a:xfrm>
+          <a:prstGeom prst="rect">
+            <a:avLst/>
+          </a:prstGeom>
+        </p:spPr>
+        <p:txBody>
+          <a:bodyPr anchor="ctr" bIns="45720" lIns="91440" rIns="91440" rtlCol="0" tIns="45720" vert="horz"/>
+          <a:lstStyle>
+            <a:lvl1pPr algn="r">
+              <a:defRPr sz="900">
+                <a:solidFill>
+                  <a:schemeClr val="tx1">
+                    <a:tint val="75000"/>
+                  </a:schemeClr>
+                </a:solidFill>
+              </a:defRPr>
+            </a:lvl1pPr>
+          </a:lstStyle>
+          <a:p>
+            <a:fld id="{C5EF2332-01BF-834F-8236-50238282D533}" type="slidenum">
+              <a:rPr lang="en-US" smtClean="0"/>
+              <a:t>‹#›</a:t>
+            </a:fld>
+            <a:endParaRPr lang="en-US"/>
+          </a:p>
+        </p:txBody>
+      </p:sp>
     </p:spTree>
+    <p:extLst>
+      <p:ext uri="{BB962C8B-B14F-4D97-AF65-F5344CB8AC3E}">
+        <p14:creationId xmlns:p14="http://schemas.microsoft.com/office/powerpoint/2010/main" val="3676200875"/>
+      </p:ext>
+    </p:extLst>
   </p:cSld>
   <p:clrMap accent1="accent1" accent2="accent2" accent3="accent3" accent4="accent4" accent5="accent5" accent6="accent6" bg1="lt1" bg2="lt2" folHlink="folHlink" hlink="hlink" tx1="dk1" tx2="dk2"/>
   <p:sldLayoutIdLst>
     <p:sldLayoutId id="2147483649" r:id="rId1"/>
-    <p:sldLayoutId id="2147483654" r:id="rId7"/>
-    <p:sldLayoutId id="2147483653" r:id="rId6"/>
-    <p:sldLayoutId id="2147483652" r:id="rId5"/>
-    <p:sldLayoutId id="2147483651" r:id="rId4"/>
-    <p:sldLayoutId id="2147483650" r:id="rId3"/>
+    <p:sldLayoutId id="2147483650" r:id="rId2"/>
+    <p:sldLayoutId id="2147483651" r:id="rId3"/>
+    <p:sldLayoutId id="2147483652" r:id="rId4"/>
+    <p:sldLayoutId id="2147483653" r:id="rId5"/>
+    <p:sldLayoutId id="2147483654" r:id="rId6"/>
+    <p:sldLayoutId id="2147483655" r:id="rId7"/>
+    <p:sldLayoutId id="2147483656" r:id="rId8"/>
+    <p:sldLayoutId id="2147483657" r:id="rId9"/>
+    <p:sldLayoutId id="2147483658" r:id="rId10"/>
+    <p:sldLayoutId id="2147483659" r:id="rId11"/>
   </p:sldLayoutIdLst>
   <p:txStyles>
-    <p:titleStyle/>
-    <p:bodyStyle/>
-    <p:otherStyle/>
+    <p:titleStyle>
+      <a:lvl1pPr algn="ctr" defTabSz="342900" eaLnBrk="1" hangingPunct="1" latinLnBrk="0" rtl="0">
+        <a:spcBef>
+          <a:spcPct val="0"/>
+        </a:spcBef>
+        <a:buNone/>
+        <a:defRPr kern="1200" sz="3300">
+          <a:solidFill>
+            <a:schemeClr val="tx1"/>
+          </a:solidFill>
+          <a:latin typeface="+mj-lt"/>
+          <a:ea typeface="+mj-ea"/>
+          <a:cs typeface="+mj-cs"/>
+        </a:defRPr>
+      </a:lvl1pPr>
+    </p:titleStyle>
+    <p:bodyStyle>
+      <a:lvl1pPr algn="l" defTabSz="342900" eaLnBrk="1" hangingPunct="1" indent="-342900" latinLnBrk="0" marL="342900" rtl="0">
+        <a:spcBef>
+          <a:spcPct val="20000"/>
+        </a:spcBef>
+        <a:buFont typeface="Arial"/>
+        <a:buChar char="•"/>
+        <a:defRPr kern="1200" sz="2400">
+          <a:solidFill>
+            <a:schemeClr val="tx1"/>
+          </a:solidFill>
+          <a:latin typeface="+mn-lt"/>
+          <a:ea typeface="+mn-ea"/>
+          <a:cs typeface="+mn-cs"/>
+        </a:defRPr>
+      </a:lvl1pPr>
+      <a:lvl2pPr algn="l" defTabSz="342900" eaLnBrk="1" hangingPunct="1" indent="-342900" latinLnBrk="0" marL="685800" rtl="0">
+        <a:spcBef>
+          <a:spcPct val="20000"/>
+        </a:spcBef>
+        <a:buFont typeface="Arial"/>
+        <a:buChar char="–"/>
+        <a:defRPr kern="1200" sz="2100">
+          <a:solidFill>
+            <a:schemeClr val="tx1"/>
+          </a:solidFill>
+          <a:latin typeface="+mn-lt"/>
+          <a:ea typeface="+mn-ea"/>
+          <a:cs typeface="+mn-cs"/>
+        </a:defRPr>
+      </a:lvl2pPr>
+      <a:lvl3pPr algn="l" defTabSz="342900" eaLnBrk="1" hangingPunct="1" indent="-342900" latinLnBrk="0" marL="1028700" rtl="0">
+        <a:spcBef>
+          <a:spcPct val="20000"/>
+        </a:spcBef>
+        <a:buFont typeface="Arial"/>
+        <a:buChar char="•"/>
+        <a:defRPr kern="1200" sz="1800">
+          <a:solidFill>
+            <a:schemeClr val="tx1"/>
+          </a:solidFill>
+          <a:latin typeface="+mn-lt"/>
+          <a:ea typeface="+mn-ea"/>
+          <a:cs typeface="+mn-cs"/>
+        </a:defRPr>
+      </a:lvl3pPr>
+      <a:lvl4pPr algn="l" defTabSz="342900" eaLnBrk="1" hangingPunct="1" indent="-342900" latinLnBrk="0" marL="1371600" rtl="0">
+        <a:spcBef>
+          <a:spcPct val="20000"/>
+        </a:spcBef>
+        <a:buFont typeface="Arial"/>
+        <a:buChar char="–"/>
+        <a:defRPr kern="1200" sz="1500">
+          <a:solidFill>
+            <a:schemeClr val="tx1"/>
+          </a:solidFill>
+          <a:latin typeface="+mn-lt"/>
+          <a:ea typeface="+mn-ea"/>
+          <a:cs typeface="+mn-cs"/>
+        </a:defRPr>
+      </a:lvl4pPr>
+      <a:lvl5pPr algn="l" defTabSz="342900" eaLnBrk="1" hangingPunct="1" indent="-342900" latinLnBrk="0" marL="1714500" rtl="0">
+        <a:spcBef>
+          <a:spcPct val="20000"/>
+        </a:spcBef>
+        <a:buFont typeface="Arial"/>
+        <a:buChar char="»"/>
+        <a:defRPr kern="1200" sz="1500">
+          <a:solidFill>
+            <a:schemeClr val="tx1"/>
+          </a:solidFill>
+          <a:latin typeface="+mn-lt"/>
+          <a:ea typeface="+mn-ea"/>
+          <a:cs typeface="+mn-cs"/>
+        </a:defRPr>
+      </a:lvl5pPr>
+      <a:lvl6pPr algn="l" defTabSz="342900" eaLnBrk="1" hangingPunct="1" indent="-342900" latinLnBrk="0" marL="2057400" rtl="0">
+        <a:spcBef>
+          <a:spcPct val="20000"/>
+        </a:spcBef>
+        <a:buFont typeface="Arial"/>
+        <a:buChar char="•"/>
+        <a:defRPr kern="1200" sz="1500">
+          <a:solidFill>
+            <a:schemeClr val="tx1"/>
+          </a:solidFill>
+          <a:latin typeface="+mn-lt"/>
+          <a:ea typeface="+mn-ea"/>
+          <a:cs typeface="+mn-cs"/>
+        </a:defRPr>
+      </a:lvl6pPr>
+      <a:lvl7pPr algn="l" defTabSz="342900" eaLnBrk="1" hangingPunct="1" indent="-342900" latinLnBrk="0" marL="2400300" rtl="0">
+        <a:spcBef>
+          <a:spcPct val="20000"/>
+        </a:spcBef>
+        <a:buFont typeface="Arial"/>
+        <a:buChar char="•"/>
+        <a:defRPr kern="1200" sz="1500">
+          <a:solidFill>
+            <a:schemeClr val="tx1"/>
+          </a:solidFill>
+          <a:latin typeface="+mn-lt"/>
+          <a:ea typeface="+mn-ea"/>
+          <a:cs typeface="+mn-cs"/>
+        </a:defRPr>
+      </a:lvl7pPr>
+      <a:lvl8pPr algn="l" defTabSz="342900" eaLnBrk="1" hangingPunct="1" indent="-342900" latinLnBrk="0" marL="2743200" rtl="0">
+        <a:spcBef>
+          <a:spcPct val="20000"/>
+        </a:spcBef>
+        <a:buFont typeface="Arial"/>
+        <a:buChar char="•"/>
+        <a:defRPr kern="1200" sz="1500">
+          <a:solidFill>
+            <a:schemeClr val="tx1"/>
+          </a:solidFill>
+          <a:latin typeface="+mn-lt"/>
+          <a:ea typeface="+mn-ea"/>
+          <a:cs typeface="+mn-cs"/>
+        </a:defRPr>
+      </a:lvl8pPr>
+      <a:lvl9pPr algn="l" defTabSz="342900" eaLnBrk="1" hangingPunct="1" indent="-342900" latinLnBrk="0" marL="3086100" rtl="0">
+        <a:spcBef>
+          <a:spcPct val="20000"/>
+        </a:spcBef>
+        <a:buFont typeface="Arial"/>
+        <a:buChar char="•"/>
+        <a:defRPr kern="1200" sz="1500">
+          <a:solidFill>
+            <a:schemeClr val="tx1"/>
+          </a:solidFill>
+          <a:latin typeface="+mn-lt"/>
+          <a:ea typeface="+mn-ea"/>
+          <a:cs typeface="+mn-cs"/>
+        </a:defRPr>
+      </a:lvl9pPr>
+    </p:bodyStyle>
+    <p:otherStyle>
+      <a:defPPr>
+        <a:defRPr lang="en-US"/>
+      </a:defPPr>
+      <a:lvl1pPr algn="l" defTabSz="342900" eaLnBrk="1" hangingPunct="1" latinLnBrk="0" marL="0" rtl="0">
+        <a:defRPr kern="1200" sz="1350">
+          <a:solidFill>
+            <a:schemeClr val="tx1"/>
+          </a:solidFill>
+          <a:latin typeface="+mn-lt"/>
+          <a:ea typeface="+mn-ea"/>
+          <a:cs typeface="+mn-cs"/>
+        </a:defRPr>
+      </a:lvl1pPr>
+      <a:lvl2pPr algn="l" defTabSz="342900" eaLnBrk="1" hangingPunct="1" latinLnBrk="0" marL="342900" rtl="0">
+        <a:defRPr kern="1200" sz="1350">
+          <a:solidFill>
+            <a:schemeClr val="tx1"/>
+          </a:solidFill>
+          <a:latin typeface="+mn-lt"/>
+          <a:ea typeface="+mn-ea"/>
+          <a:cs typeface="+mn-cs"/>
+        </a:defRPr>
+      </a:lvl2pPr>
+      <a:lvl3pPr algn="l" defTabSz="342900" eaLnBrk="1" hangingPunct="1" latinLnBrk="0" marL="685800" rtl="0">
+        <a:defRPr kern="1200" sz="1350">
+          <a:solidFill>
+            <a:schemeClr val="tx1"/>
+          </a:solidFill>
+          <a:latin typeface="+mn-lt"/>
+          <a:ea typeface="+mn-ea"/>
+          <a:cs typeface="+mn-cs"/>
+        </a:defRPr>
+      </a:lvl3pPr>
+      <a:lvl4pPr algn="l" defTabSz="342900" eaLnBrk="1" hangingPunct="1" latinLnBrk="0" marL="1028700" rtl="0">
+        <a:defRPr kern="1200" sz="1350">
+          <a:solidFill>
+            <a:schemeClr val="tx1"/>
+          </a:solidFill>
+          <a:latin typeface="+mn-lt"/>
+          <a:ea typeface="+mn-ea"/>
+          <a:cs typeface="+mn-cs"/>
+        </a:defRPr>
+      </a:lvl4pPr>
+      <a:lvl5pPr algn="l" defTabSz="342900" eaLnBrk="1" hangingPunct="1" latinLnBrk="0" marL="1371600" rtl="0">
+        <a:defRPr kern="1200" sz="1350">
+          <a:solidFill>
+            <a:schemeClr val="tx1"/>
+          </a:solidFill>
+          <a:latin typeface="+mn-lt"/>
+          <a:ea typeface="+mn-ea"/>
+          <a:cs typeface="+mn-cs"/>
+        </a:defRPr>
+      </a:lvl5pPr>
+      <a:lvl6pPr algn="l" defTabSz="342900" eaLnBrk="1" hangingPunct="1" latinLnBrk="0" marL="1714500" rtl="0">
+        <a:defRPr kern="1200" sz="1350">
+          <a:solidFill>
+            <a:schemeClr val="tx1"/>
+          </a:solidFill>
+          <a:latin typeface="+mn-lt"/>
+          <a:ea typeface="+mn-ea"/>
+          <a:cs typeface="+mn-cs"/>
+        </a:defRPr>
+      </a:lvl6pPr>
+      <a:lvl7pPr algn="l" defTabSz="342900" eaLnBrk="1" hangingPunct="1" latinLnBrk="0" marL="2057400" rtl="0">
+        <a:defRPr kern="1200" sz="1350">
+          <a:solidFill>
+            <a:schemeClr val="tx1"/>
+          </a:solidFill>
+          <a:latin typeface="+mn-lt"/>
+          <a:ea typeface="+mn-ea"/>
+          <a:cs typeface="+mn-cs"/>
+        </a:defRPr>
+      </a:lvl7pPr>
+      <a:lvl8pPr algn="l" defTabSz="342900" eaLnBrk="1" hangingPunct="1" latinLnBrk="0" marL="2400300" rtl="0">
+        <a:defRPr kern="1200" sz="1350">
+          <a:solidFill>
+            <a:schemeClr val="tx1"/>
+          </a:solidFill>
+          <a:latin typeface="+mn-lt"/>
+          <a:ea typeface="+mn-ea"/>
+          <a:cs typeface="+mn-cs"/>
+        </a:defRPr>
+      </a:lvl8pPr>
+      <a:lvl9pPr algn="l" defTabSz="342900" eaLnBrk="1" hangingPunct="1" latinLnBrk="0" marL="2743200" rtl="0">
+        <a:defRPr kern="1200" sz="1350">
+          <a:solidFill>
+            <a:schemeClr val="tx1"/>
+          </a:solidFill>
+          <a:latin typeface="+mn-lt"/>
+          <a:ea typeface="+mn-ea"/>
+          <a:cs typeface="+mn-cs"/>
+        </a:defRPr>
+      </a:lvl9pPr>
+    </p:otherStyle>
   </p:txStyles>
 </p:sldMaster>
 </file>
@@ -2609,7 +3192,7 @@
           <a:bodyPr/>
           <a:lstStyle/>
           <a:p>
-            <a:pPr lvl="0">
+            <a:pPr lvl="0" indent="-342900" marL="342900">
               <a:buAutoNum type="arabicPeriod"/>
             </a:pPr>
             <a:r>
@@ -2626,7 +3209,7 @@
             </a:r>
           </a:p>
           <a:p>
-            <a:pPr lvl="0">
+            <a:pPr lvl="0" indent="-342900" marL="342900">
               <a:buAutoNum type="arabicPeriod"/>
             </a:pPr>
             <a:r>
@@ -2635,7 +3218,7 @@
             </a:r>
           </a:p>
           <a:p>
-            <a:pPr lvl="0">
+            <a:pPr lvl="0" indent="-342900" marL="342900">
               <a:buAutoNum type="arabicPeriod"/>
             </a:pPr>
             <a:r>
@@ -2644,7 +3227,7 @@
             </a:r>
           </a:p>
           <a:p>
-            <a:pPr lvl="0">
+            <a:pPr lvl="0" indent="-342900" marL="342900">
               <a:buAutoNum type="arabicPeriod"/>
             </a:pPr>
             <a:r>
@@ -5135,7 +5718,7 @@
           <a:bodyPr/>
           <a:lstStyle/>
           <a:p>
-            <a:pPr lvl="0">
+            <a:pPr lvl="0" indent="-342900" marL="342900">
               <a:buAutoNum type="arabicPeriod"/>
             </a:pPr>
             <a:r>
@@ -5154,7 +5737,7 @@
             </a:r>
           </a:p>
           <a:p>
-            <a:pPr lvl="0">
+            <a:pPr lvl="0" indent="-342900" marL="342900">
               <a:buAutoNum type="arabicPeriod"/>
             </a:pPr>
             <a:r>
@@ -5173,7 +5756,7 @@
             </a:r>
           </a:p>
           <a:p>
-            <a:pPr lvl="0">
+            <a:pPr lvl="0" indent="-342900" marL="342900">
               <a:buAutoNum type="arabicPeriod"/>
             </a:pPr>
             <a:r>
@@ -5192,7 +5775,7 @@
             </a:r>
           </a:p>
           <a:p>
-            <a:pPr lvl="0">
+            <a:pPr lvl="0" indent="-342900" marL="342900">
               <a:buAutoNum type="arabicPeriod"/>
             </a:pPr>
             <a:r>
@@ -5211,7 +5794,7 @@
             </a:r>
           </a:p>
           <a:p>
-            <a:pPr lvl="0">
+            <a:pPr lvl="0" indent="-342900" marL="342900">
               <a:buAutoNum type="arabicPeriod"/>
             </a:pPr>
             <a:r>
@@ -5240,7 +5823,7 @@
             </a:r>
           </a:p>
           <a:p>
-            <a:pPr lvl="0">
+            <a:pPr lvl="0" indent="-342900" marL="342900">
               <a:buAutoNum type="arabicPeriod"/>
             </a:pPr>
             <a:r>
@@ -5259,7 +5842,7 @@
             </a:r>
           </a:p>
           <a:p>
-            <a:pPr lvl="0">
+            <a:pPr lvl="0" indent="-342900" marL="342900">
               <a:buAutoNum type="arabicPeriod"/>
             </a:pPr>
             <a:r>
@@ -5288,7 +5871,7 @@
             </a:r>
           </a:p>
           <a:p>
-            <a:pPr lvl="0">
+            <a:pPr lvl="0" indent="-342900" marL="342900">
               <a:buAutoNum type="arabicPeriod"/>
             </a:pPr>
             <a:r>
@@ -5307,7 +5890,7 @@
             </a:r>
           </a:p>
           <a:p>
-            <a:pPr lvl="0">
+            <a:pPr lvl="0" indent="-342900" marL="342900">
               <a:buAutoNum type="arabicPeriod"/>
             </a:pPr>
             <a:r>
@@ -5326,7 +5909,7 @@
             </a:r>
           </a:p>
           <a:p>
-            <a:pPr lvl="0">
+            <a:pPr lvl="0" indent="-342900" marL="342900">
               <a:buAutoNum type="arabicPeriod"/>
             </a:pPr>
             <a:r>
@@ -5335,7 +5918,7 @@
             </a:r>
           </a:p>
           <a:p>
-            <a:pPr lvl="0">
+            <a:pPr lvl="0" indent="-342900" marL="342900">
               <a:buAutoNum type="arabicPeriod"/>
             </a:pPr>
             <a:r>
@@ -5344,7 +5927,7 @@
             </a:r>
           </a:p>
           <a:p>
-            <a:pPr lvl="0">
+            <a:pPr lvl="0" indent="-342900" marL="342900">
               <a:buAutoNum type="arabicPeriod"/>
             </a:pPr>
             <a:r>
@@ -5379,79 +5962,322 @@
 </file>
 
 <file path=ppt/theme/theme1.xml><?xml version="1.0" encoding="utf-8"?>
-<a:theme xmlns:a="http://schemas.openxmlformats.org/drawingml/2006/main" name="OpenERP">
+<a:theme xmlns:a="http://schemas.openxmlformats.org/drawingml/2006/main" name="Office Theme">
   <a:themeElements>
-    <a:clrScheme name="OpenERP">
+    <a:clrScheme name="Office">
       <a:dk1>
-        <a:srgbClr val="172033"/>
+        <a:sysClr val="windowText" lastClr="000000"/>
       </a:dk1>
       <a:lt1>
-        <a:srgbClr val="FFFFFF"/>
+        <a:sysClr val="window" lastClr="FFFFFF"/>
       </a:lt1>
       <a:dk2>
-        <a:srgbClr val="334155"/>
+        <a:srgbClr val="1F497D"/>
       </a:dk2>
       <a:lt2>
-        <a:srgbClr val="F7F9FC"/>
+        <a:srgbClr val="EEECE1"/>
       </a:lt2>
       <a:accent1>
-        <a:srgbClr val="0F9F9A"/>
+        <a:srgbClr val="4F81BD"/>
       </a:accent1>
       <a:accent2>
-        <a:srgbClr val="2563EB"/>
+        <a:srgbClr val="C0504D"/>
       </a:accent2>
       <a:accent3>
-        <a:srgbClr val="1E9B57"/>
+        <a:srgbClr val="9BBB59"/>
       </a:accent3>
       <a:accent4>
-        <a:srgbClr val="D89000"/>
+        <a:srgbClr val="8064A2"/>
       </a:accent4>
       <a:accent5>
-        <a:srgbClr val="6D5BD0"/>
+        <a:srgbClr val="4BACC6"/>
       </a:accent5>
       <a:accent6>
-        <a:srgbClr val="C2413B"/>
+        <a:srgbClr val="F79646"/>
       </a:accent6>
       <a:hlink>
-        <a:srgbClr val="2563EB"/>
+        <a:srgbClr val="0000FF"/>
       </a:hlink>
       <a:folHlink>
-        <a:srgbClr val="6D5BD0"/>
+        <a:srgbClr val="800080"/>
       </a:folHlink>
     </a:clrScheme>
-    <a:fontScheme name="OpenERP">
+    <a:fontScheme name="Office">
       <a:majorFont>
-        <a:latin typeface="DejaVu Sans"/>
+        <a:latin typeface="Calibri"/>
+        <a:ea typeface=""/>
+        <a:cs typeface=""/>
+        <a:font script="Jpan" typeface="ＭＳ Ｐゴシック"/>
+        <a:font script="Hang" typeface="맑은 고딕"/>
+        <a:font script="Hans" typeface="宋体"/>
+        <a:font script="Hant" typeface="新細明體"/>
+        <a:font script="Arab" typeface="Times New Roman"/>
+        <a:font script="Hebr" typeface="Times New Roman"/>
+        <a:font script="Thai" typeface="Angsana New"/>
+        <a:font script="Ethi" typeface="Nyala"/>
+        <a:font script="Beng" typeface="Vrinda"/>
+        <a:font script="Gujr" typeface="Shruti"/>
+        <a:font script="Khmr" typeface="MoolBoran"/>
+        <a:font script="Knda" typeface="Tunga"/>
+        <a:font script="Guru" typeface="Raavi"/>
+        <a:font script="Cans" typeface="Euphemia"/>
+        <a:font script="Cher" typeface="Plantagenet Cherokee"/>
+        <a:font script="Yiii" typeface="Microsoft Yi Baiti"/>
+        <a:font script="Tibt" typeface="Microsoft Himalaya"/>
+        <a:font script="Thaa" typeface="MV Boli"/>
+        <a:font script="Deva" typeface="Mangal"/>
+        <a:font script="Telu" typeface="Gautami"/>
+        <a:font script="Taml" typeface="Latha"/>
+        <a:font script="Syrc" typeface="Estrangelo Edessa"/>
+        <a:font script="Orya" typeface="Kalinga"/>
+        <a:font script="Mlym" typeface="Kartika"/>
+        <a:font script="Laoo" typeface="DokChampa"/>
+        <a:font script="Sinh" typeface="Iskoola Pota"/>
+        <a:font script="Mong" typeface="Mongolian Baiti"/>
+        <a:font script="Viet" typeface="Times New Roman"/>
+        <a:font script="Uigh" typeface="Microsoft Uighur"/>
+        <a:font script="Geor" typeface="Sylfaen"/>
       </a:majorFont>
       <a:minorFont>
-        <a:latin typeface="DejaVu Sans"/>
+        <a:latin typeface="Calibri"/>
+        <a:ea typeface=""/>
+        <a:cs typeface=""/>
+        <a:font script="Jpan" typeface="ＭＳ Ｐゴシック"/>
+        <a:font script="Hang" typeface="맑은 고딕"/>
+        <a:font script="Hans" typeface="宋体"/>
+        <a:font script="Hant" typeface="新細明體"/>
+        <a:font script="Arab" typeface="Arial"/>
+        <a:font script="Hebr" typeface="Arial"/>
+        <a:font script="Thai" typeface="Cordia New"/>
+        <a:font script="Ethi" typeface="Nyala"/>
+        <a:font script="Beng" typeface="Vrinda"/>
+        <a:font script="Gujr" typeface="Shruti"/>
+        <a:font script="Khmr" typeface="DaunPenh"/>
+        <a:font script="Knda" typeface="Tunga"/>
+        <a:font script="Guru" typeface="Raavi"/>
+        <a:font script="Cans" typeface="Euphemia"/>
+        <a:font script="Cher" typeface="Plantagenet Cherokee"/>
+        <a:font script="Yiii" typeface="Microsoft Yi Baiti"/>
+        <a:font script="Tibt" typeface="Microsoft Himalaya"/>
+        <a:font script="Thaa" typeface="MV Boli"/>
+        <a:font script="Deva" typeface="Mangal"/>
+        <a:font script="Telu" typeface="Gautami"/>
+        <a:font script="Taml" typeface="Latha"/>
+        <a:font script="Syrc" typeface="Estrangelo Edessa"/>
+        <a:font script="Orya" typeface="Kalinga"/>
+        <a:font script="Mlym" typeface="Kartika"/>
+        <a:font script="Laoo" typeface="DokChampa"/>
+        <a:font script="Sinh" typeface="Iskoola Pota"/>
+        <a:font script="Mong" typeface="Mongolian Baiti"/>
+        <a:font script="Viet" typeface="Arial"/>
+        <a:font script="Uigh" typeface="Microsoft Uighur"/>
+        <a:font script="Geor" typeface="Sylfaen"/>
       </a:minorFont>
     </a:fontScheme>
-    <a:fmtScheme name="OpenERP">
+    <a:fmtScheme name="Office">
       <a:fillStyleLst>
         <a:solidFill>
           <a:schemeClr val="phClr"/>
         </a:solidFill>
+        <a:gradFill rotWithShape="1">
+          <a:gsLst>
+            <a:gs pos="0">
+              <a:schemeClr val="phClr">
+                <a:tint val="50000"/>
+                <a:satMod val="300000"/>
+              </a:schemeClr>
+            </a:gs>
+            <a:gs pos="35000">
+              <a:schemeClr val="phClr">
+                <a:tint val="37000"/>
+                <a:satMod val="300000"/>
+              </a:schemeClr>
+            </a:gs>
+            <a:gs pos="100000">
+              <a:schemeClr val="phClr">
+                <a:tint val="15000"/>
+                <a:satMod val="350000"/>
+              </a:schemeClr>
+            </a:gs>
+          </a:gsLst>
+          <a:lin ang="16200000" scaled="1"/>
+        </a:gradFill>
+        <a:gradFill rotWithShape="1">
+          <a:gsLst>
+            <a:gs pos="0">
+              <a:schemeClr val="phClr">
+                <a:tint val="100000"/>
+                <a:shade val="100000"/>
+                <a:satMod val="130000"/>
+              </a:schemeClr>
+            </a:gs>
+            <a:gs pos="100000">
+              <a:schemeClr val="phClr">
+                <a:tint val="50000"/>
+                <a:shade val="100000"/>
+                <a:satMod val="350000"/>
+              </a:schemeClr>
+            </a:gs>
+          </a:gsLst>
+          <a:lin ang="16200000" scaled="0"/>
+        </a:gradFill>
       </a:fillStyleLst>
       <a:lnStyleLst>
-        <a:ln w="9525">
+        <a:ln w="9525" cap="flat" cmpd="sng" algn="ctr">
+          <a:solidFill>
+            <a:schemeClr val="phClr">
+              <a:shade val="95000"/>
+              <a:satMod val="105000"/>
+            </a:schemeClr>
+          </a:solidFill>
+          <a:prstDash val="solid"/>
+        </a:ln>
+        <a:ln w="25400" cap="flat" cmpd="sng" algn="ctr">
           <a:solidFill>
             <a:schemeClr val="phClr"/>
           </a:solidFill>
+          <a:prstDash val="solid"/>
+        </a:ln>
+        <a:ln w="38100" cap="flat" cmpd="sng" algn="ctr">
+          <a:solidFill>
+            <a:schemeClr val="phClr"/>
+          </a:solidFill>
+          <a:prstDash val="solid"/>
         </a:ln>
       </a:lnStyleLst>
       <a:effectStyleLst>
         <a:effectStyle>
-          <a:effectLst/>
+          <a:effectLst>
+            <a:outerShdw blurRad="40000" dist="20000" dir="5400000" rotWithShape="0">
+              <a:srgbClr val="000000">
+                <a:alpha val="38000"/>
+              </a:srgbClr>
+            </a:outerShdw>
+          </a:effectLst>
+        </a:effectStyle>
+        <a:effectStyle>
+          <a:effectLst>
+            <a:outerShdw blurRad="40000" dist="23000" dir="5400000" rotWithShape="0">
+              <a:srgbClr val="000000">
+                <a:alpha val="35000"/>
+              </a:srgbClr>
+            </a:outerShdw>
+          </a:effectLst>
+        </a:effectStyle>
+        <a:effectStyle>
+          <a:effectLst>
+            <a:outerShdw blurRad="40000" dist="23000" dir="5400000" rotWithShape="0">
+              <a:srgbClr val="000000">
+                <a:alpha val="35000"/>
+              </a:srgbClr>
+            </a:outerShdw>
+          </a:effectLst>
+          <a:scene3d>
+            <a:camera prst="orthographicFront">
+              <a:rot lat="0" lon="0" rev="0"/>
+            </a:camera>
+            <a:lightRig rig="threePt" dir="t">
+              <a:rot lat="0" lon="0" rev="1200000"/>
+            </a:lightRig>
+          </a:scene3d>
+          <a:sp3d>
+            <a:bevelT w="63500" h="25400"/>
+          </a:sp3d>
         </a:effectStyle>
       </a:effectStyleLst>
       <a:bgFillStyleLst>
         <a:solidFill>
           <a:schemeClr val="phClr"/>
         </a:solidFill>
+        <a:gradFill rotWithShape="1">
+          <a:gsLst>
+            <a:gs pos="0">
+              <a:schemeClr val="phClr">
+                <a:tint val="40000"/>
+                <a:satMod val="350000"/>
+              </a:schemeClr>
+            </a:gs>
+            <a:gs pos="40000">
+              <a:schemeClr val="phClr">
+                <a:tint val="45000"/>
+                <a:shade val="99000"/>
+                <a:satMod val="350000"/>
+              </a:schemeClr>
+            </a:gs>
+            <a:gs pos="100000">
+              <a:schemeClr val="phClr">
+                <a:shade val="20000"/>
+                <a:satMod val="255000"/>
+              </a:schemeClr>
+            </a:gs>
+          </a:gsLst>
+          <a:path path="circle">
+            <a:fillToRect l="50000" t="-80000" r="50000" b="180000"/>
+          </a:path>
+        </a:gradFill>
+        <a:gradFill rotWithShape="1">
+          <a:gsLst>
+            <a:gs pos="0">
+              <a:schemeClr val="phClr">
+                <a:tint val="80000"/>
+                <a:satMod val="300000"/>
+              </a:schemeClr>
+            </a:gs>
+            <a:gs pos="100000">
+              <a:schemeClr val="phClr">
+                <a:shade val="30000"/>
+                <a:satMod val="200000"/>
+              </a:schemeClr>
+            </a:gs>
+          </a:gsLst>
+          <a:path path="circle">
+            <a:fillToRect l="50000" t="50000" r="50000" b="50000"/>
+          </a:path>
+        </a:gradFill>
       </a:bgFillStyleLst>
     </a:fmtScheme>
   </a:themeElements>
+  <a:objectDefaults>
+    <a:spDef>
+      <a:spPr/>
+      <a:bodyPr/>
+      <a:lstStyle/>
+      <a:style>
+        <a:lnRef idx="1">
+          <a:schemeClr val="accent1"/>
+        </a:lnRef>
+        <a:fillRef idx="3">
+          <a:schemeClr val="accent1"/>
+        </a:fillRef>
+        <a:effectRef idx="2">
+          <a:schemeClr val="accent1"/>
+        </a:effectRef>
+        <a:fontRef idx="minor">
+          <a:schemeClr val="lt1"/>
+        </a:fontRef>
+      </a:style>
+    </a:spDef>
+    <a:lnDef>
+      <a:spPr/>
+      <a:bodyPr/>
+      <a:lstStyle/>
+      <a:style>
+        <a:lnRef idx="2">
+          <a:schemeClr val="accent1"/>
+        </a:lnRef>
+        <a:fillRef idx="0">
+          <a:schemeClr val="accent1"/>
+        </a:fillRef>
+        <a:effectRef idx="1">
+          <a:schemeClr val="accent1"/>
+        </a:effectRef>
+        <a:fontRef idx="minor">
+          <a:schemeClr val="tx1"/>
+        </a:fontRef>
+      </a:style>
+    </a:lnDef>
+  </a:objectDefaults>
+  <a:extraClrSchemeLst/>
 </a:theme>
 </file>
 

</xml_diff>

<commit_message>
Engrave MVP decisions arbitrated 2026-05-14 across 6 specs and decision-pack
</commit_message>
<xml_diff>
--- a/docs/study/10-mvp-specs/decision-pack.pptx
+++ b/docs/study/10-mvp-specs/decision-pack.pptx
@@ -3267,7 +3267,7 @@
                 </a:solidFill>
                 <a:latin typeface="Calibri"/>
               </a:rPr>
-              <a:t>Sprint cadrage MVP OpenERP — arbitrage porteur produit</a:t>
+              <a:t>Sprint cadrage MVP OpenERP — synthèse arbitrage</a:t>
             </a:r>
           </a:p>
         </p:txBody>
@@ -3302,7 +3302,7 @@
                 </a:solidFill>
                 <a:latin typeface="Calibri"/>
               </a:rPr>
-              <a:t>2026-05-13</a:t>
+              <a:t>2026-05-14 · Toutes décisions programme RESOLVED</a:t>
             </a:r>
           </a:p>
         </p:txBody>
@@ -3337,7 +3337,7 @@
                 </a:solidFill>
                 <a:latin typeface="Calibri"/>
               </a:rPr>
-              <a:t>6 specs MVP enrichies · double revue Claude + codex · 12 décisions programme</a:t>
+              <a:t>6 specs MVP enrichies · double revue Claude + codex · 12 décisions programme arbitrées</a:t>
             </a:r>
           </a:p>
         </p:txBody>
@@ -3469,7 +3469,7 @@
                 </a:solidFill>
                 <a:latin typeface="Calibri"/>
               </a:rPr>
-              <a:t>MVP Decision Pack — 2026-05-13</a:t>
+              <a:t>MVP Decision Pack — 2026-05-14</a:t>
             </a:r>
           </a:p>
         </p:txBody>
@@ -3539,7 +3539,7 @@
                 </a:solidFill>
                 <a:latin typeface="Calibri"/>
               </a:rPr>
-              <a:t>Canon entités partagées</a:t>
+              <a:t>Canon entités partagées (4 articles)</a:t>
             </a:r>
           </a:p>
         </p:txBody>
@@ -3559,7 +3559,7 @@
             <a:avLst/>
           </a:prstGeom>
           <a:solidFill>
-            <a:srgbClr val="DC2626"/>
+            <a:srgbClr val="059669"/>
           </a:solidFill>
           <a:ln>
             <a:noFill/>
@@ -3591,7 +3591,7 @@
                 </a:solidFill>
                 <a:latin typeface="Calibri"/>
               </a:rPr>
-              <a:t>P0</a:t>
+              <a:t>RESOLVED</a:t>
             </a:r>
           </a:p>
         </p:txBody>
@@ -3705,7 +3705,7 @@
                 </a:solidFill>
                 <a:latin typeface="Calibri"/>
               </a:rPr>
-              <a:t>Codex propose un canon transverse cohérent à valider en bloc. Sans ce canon, chaque module réinvente.</a:t>
+              <a:t>Codex propose un canon transverse cohérent à valider en bloc. Ce ne sont PAS des options alternatives mais les 4 articles du canon à graver. Sans ce canon, chaque module réinvente.</a:t>
             </a:r>
           </a:p>
         </p:txBody>
@@ -3854,7 +3854,7 @@
                 </a:solidFill>
                 <a:latin typeface="Calibri"/>
               </a:rPr>
-              <a:t>Organization (métier) + tenant (runtime), Money = {amount_minor, currency, scale}</a:t>
+              <a:t>Article 1 : Organization (métier) + tenant (runtime), Money = {amount_minor, currency(3), scale}</a:t>
             </a:r>
           </a:p>
         </p:txBody>
@@ -3924,7 +3924,7 @@
                 </a:solidFill>
                 <a:latin typeface="Calibri"/>
               </a:rPr>
-              <a:t>AuditEvent / DomainEvent / TimelineEntry séparés (3 couches)</a:t>
+              <a:t>Article 2 : AuditEvent / DomainEvent / TimelineEntry séparés (3 couches)</a:t>
             </a:r>
           </a:p>
         </p:txBody>
@@ -3994,7 +3994,7 @@
                 </a:solidFill>
                 <a:latin typeface="Calibri"/>
               </a:rPr>
-              <a:t>Activity préfixé : CrmActivity, ProjectTask, ServiceActivity, AgentRun</a:t>
+              <a:t>Article 3 : Activity préfixé : CrmActivity, ProjectTask, ServiceActivity, AgentRun</a:t>
             </a:r>
           </a:p>
         </p:txBody>
@@ -4064,7 +4064,7 @@
                 </a:solidFill>
                 <a:latin typeface="Calibri"/>
               </a:rPr>
-              <a:t>Company entité + customer = rôle ; Project owns InvoiceProposal, Billing owns Invoice</a:t>
+              <a:t>Article 4 : Company entité + customer = rôle ; Project owns InvoiceProposal, Billing owns Invoice</a:t>
             </a:r>
           </a:p>
         </p:txBody>
@@ -4178,7 +4178,7 @@
                 </a:solidFill>
                 <a:latin typeface="Calibri"/>
               </a:rPr>
-              <a:t>Validation en bloc + création docs/study/10-mvp-specs/shared-entities-v1.md comme contrat transverse.</a:t>
+              <a:t>✓ Arbitré 2026-05-14 : canon adopté en bloc. Création docs/study/10-mvp-specs/shared-entities-v1.md comme contrat transverse à la prochaine étape.</a:t>
             </a:r>
           </a:p>
         </p:txBody>
@@ -4459,7 +4459,7 @@
                 </a:solidFill>
                 <a:latin typeface="Calibri"/>
               </a:rPr>
-              <a:t>MVP Decision Pack — 2026-05-13</a:t>
+              <a:t>MVP Decision Pack — 2026-05-14</a:t>
             </a:r>
           </a:p>
         </p:txBody>
@@ -4549,7 +4549,7 @@
             <a:avLst/>
           </a:prstGeom>
           <a:solidFill>
-            <a:srgbClr val="D97606"/>
+            <a:srgbClr val="059669"/>
           </a:solidFill>
           <a:ln>
             <a:noFill/>
@@ -4581,7 +4581,7 @@
                 </a:solidFill>
                 <a:latin typeface="Calibri"/>
               </a:rPr>
-              <a:t>P1</a:t>
+              <a:t>RESOLVED</a:t>
             </a:r>
           </a:p>
         </p:txBody>
@@ -5098,7 +5098,7 @@
                 </a:solidFill>
                 <a:latin typeface="Calibri"/>
               </a:rPr>
-              <a:t>Entité ApprovalRequest foundation : {request_id, requester, approver, subject_type, subject_id, status, decision_reason, decided_at}. Consommée par CRM, project, billing, agentic.</a:t>
+              <a:t>✓ Arbitré 2026-05-14 : (b) ApprovalRequest foundation, exposée via 3 surfaces — API REST, tool MCP request_approval(), SDK @sentropic/openerp-sdk. Codex et Claude consomment le même tool schema.</a:t>
             </a:r>
           </a:p>
         </p:txBody>
@@ -5379,7 +5379,7 @@
                 </a:solidFill>
                 <a:latin typeface="Calibri"/>
               </a:rPr>
-              <a:t>MVP Decision Pack — 2026-05-13</a:t>
+              <a:t>MVP Decision Pack — 2026-05-14</a:t>
             </a:r>
           </a:p>
         </p:txBody>
@@ -5469,7 +5469,7 @@
             <a:avLst/>
           </a:prstGeom>
           <a:solidFill>
-            <a:srgbClr val="D97606"/>
+            <a:srgbClr val="059669"/>
           </a:solidFill>
           <a:ln>
             <a:noFill/>
@@ -5501,7 +5501,7 @@
                 </a:solidFill>
                 <a:latin typeface="Calibri"/>
               </a:rPr>
-              <a:t>P1</a:t>
+              <a:t>RESOLVED</a:t>
             </a:r>
           </a:p>
         </p:txBody>
@@ -5615,7 +5615,7 @@
                 </a:solidFill>
                 <a:latin typeface="Calibri"/>
               </a:rPr>
-              <a:t>Foundation propose Idempotency-Key sur 4 endpoints sensibles. Trop restrictif (les deux reviewers d'accord).</a:t>
+              <a:t>Header HTTP Idempotency-Key envoyé par le client sur POST/DELETE. Serveur stocke (key, response) en DB ; replay → cache hit. Évite double facturation, double agent run, double import sur retry réseau.</a:t>
             </a:r>
           </a:p>
         </p:txBody>
@@ -6018,7 +6018,7 @@
                 </a:solidFill>
                 <a:latin typeface="Calibri"/>
               </a:rPr>
-              <a:t>Idempotency-Key header obligatoire sur toute POST/DELETE à side-effect métier. Pattern foundation, business id sert de seed.</a:t>
+              <a:t>✓ Arbitré 2026-05-14 : (b) Idempotency-Key obligatoire sur toute POST/DELETE à side-effect métier. TTL 24h, table IdempotencyRecord en foundation. Middleware pattern (Stripe).</a:t>
             </a:r>
           </a:p>
         </p:txBody>
@@ -6299,7 +6299,7 @@
                 </a:solidFill>
                 <a:latin typeface="Calibri"/>
               </a:rPr>
-              <a:t>MVP Decision Pack — 2026-05-13</a:t>
+              <a:t>MVP Decision Pack — 2026-05-14</a:t>
             </a:r>
           </a:p>
         </p:txBody>
@@ -6369,7 +6369,7 @@
                 </a:solidFill>
                 <a:latin typeface="Calibri"/>
               </a:rPr>
-              <a:t>Identité agent</a:t>
+              <a:t>Identité agent + délégation</a:t>
             </a:r>
           </a:p>
         </p:txBody>
@@ -6389,7 +6389,7 @@
             <a:avLst/>
           </a:prstGeom>
           <a:solidFill>
-            <a:srgbClr val="D97606"/>
+            <a:srgbClr val="059669"/>
           </a:solidFill>
           <a:ln>
             <a:noFill/>
@@ -6421,7 +6421,7 @@
                 </a:solidFill>
                 <a:latin typeface="Calibri"/>
               </a:rPr>
-              <a:t>P1</a:t>
+              <a:t>RESOLVED</a:t>
             </a:r>
           </a:p>
         </p:txBody>
@@ -6535,7 +6535,7 @@
                 </a:solidFill>
                 <a:latin typeface="Calibri"/>
               </a:rPr>
-              <a:t>Agentic propose JWT signé OpenERP-native. Foundation auth = cookie HTTP-only humain. Pont à formaliser.</a:t>
+              <a:t>JWT seul insuffisant. Délégation d'action et policy association = objectif clé pour enabler l'agentique. Audit-grade traceabilité requise.</a:t>
             </a:r>
           </a:p>
         </p:txBody>
@@ -6684,7 +6684,7 @@
                 </a:solidFill>
                 <a:latin typeface="Calibri"/>
               </a:rPr>
-              <a:t>Hybride : cookie humains + JWT signé agents</a:t>
+              <a:t>MVP : JWT + RFC 8693 token exchange (act / may_act claims)</a:t>
             </a:r>
           </a:p>
         </p:txBody>
@@ -6754,7 +6754,7 @@
                 </a:solidFill>
                 <a:latin typeface="Calibri"/>
               </a:rPr>
-              <a:t>SPIFFE / SVID (overkill MVP)</a:t>
+              <a:t>Post-MVP : SPIFFE/SVID workload attestation (CNCF, aligné NIST SP 800-204)</a:t>
             </a:r>
           </a:p>
         </p:txBody>
@@ -6824,7 +6824,7 @@
                 </a:solidFill>
                 <a:latin typeface="Calibri"/>
               </a:rPr>
-              <a:t>OIDC subject extension</a:t>
+              <a:t>Policy binding : AgentDefinition.allowed_tools, max_spend, requires_approval_above</a:t>
             </a:r>
           </a:p>
         </p:txBody>
@@ -6938,7 +6938,7 @@
                 </a:solidFill>
                 <a:latin typeface="Calibri"/>
               </a:rPr>
-              <a:t>Hybride. User.actor_type = human | agent | system. Foundation expose verify JWT + claims acting_for / on_behalf_of.</a:t>
+              <a:t>✓ Arbitré 2026-05-14 : stack hybride. MVP RFC 8693 token exchange + ApprovalRequest comme issuance. SPIFFE post-MVP via abstraction IdentityProvider. Cookie humains + JWT signé agents. AuditEvent étendu avec acting_principal + on_behalf_of + policy_decision_id.</a:t>
             </a:r>
           </a:p>
         </p:txBody>
@@ -7052,7 +7052,7 @@
                 </a:solidFill>
                 <a:latin typeface="Calibri"/>
               </a:rPr>
-              <a:t>Foundation + Agentic décident ensemble · Bloque tout flow d'agent autonome</a:t>
+              <a:t>Foundation + Agentic décident ensemble · Bloque tout flow d'agent autonome · Chaîne délégation auditable de bout en bout</a:t>
             </a:r>
           </a:p>
         </p:txBody>
@@ -7219,7 +7219,7 @@
                 </a:solidFill>
                 <a:latin typeface="Calibri"/>
               </a:rPr>
-              <a:t>MVP Decision Pack — 2026-05-13</a:t>
+              <a:t>MVP Decision Pack — 2026-05-14</a:t>
             </a:r>
           </a:p>
         </p:txBody>
@@ -7309,7 +7309,7 @@
             <a:avLst/>
           </a:prstGeom>
           <a:solidFill>
-            <a:srgbClr val="D97606"/>
+            <a:srgbClr val="059669"/>
           </a:solidFill>
           <a:ln>
             <a:noFill/>
@@ -7341,7 +7341,7 @@
                 </a:solidFill>
                 <a:latin typeface="Calibri"/>
               </a:rPr>
-              <a:t>P1</a:t>
+              <a:t>RESOLVED</a:t>
             </a:r>
           </a:p>
         </p:txBody>
@@ -7858,7 +7858,7 @@
                 </a:solidFill>
                 <a:latin typeface="Calibri"/>
               </a:rPr>
-              <a:t>Native SvelteKit + primitive Widget foundation. Superset/Grafana en pack post-MVP optionnel. Évite Superset-clone tentation.</a:t>
+              <a:t>✓ Arbitré 2026-05-14 : (a) primitive Widget foundation, coordination tokens/composants avec @sent-tech à clarifier. Veille charts Svelte (layerchart, svelte-echarts, chart.js, observable plot) à dispatcher. Aspiration VizQL post-MVP.</a:t>
             </a:r>
           </a:p>
         </p:txBody>
@@ -7972,7 +7972,7 @@
                 </a:solidFill>
                 <a:latin typeface="Calibri"/>
               </a:rPr>
-              <a:t>Touche reporting + CRM dashboards + project dashboards + billing dashboards · Économise dépendance Selenium/Chromium</a:t>
+              <a:t>Touche reporting + CRM dashboards + project dashboards + billing dashboards · Évite dépendance Selenium/Chromium</a:t>
             </a:r>
           </a:p>
         </p:txBody>
@@ -8139,7 +8139,7 @@
                 </a:solidFill>
                 <a:latin typeface="Calibri"/>
               </a:rPr>
-              <a:t>MVP Decision Pack — 2026-05-13</a:t>
+              <a:t>MVP Decision Pack — 2026-05-14</a:t>
             </a:r>
           </a:p>
         </p:txBody>
@@ -8209,7 +8209,7 @@
                 </a:solidFill>
                 <a:latin typeface="Calibri"/>
               </a:rPr>
-              <a:t>Stack PDF rendering</a:t>
+              <a:t>Stack templating (docx + pdf)</a:t>
             </a:r>
           </a:p>
         </p:txBody>
@@ -8229,7 +8229,7 @@
             <a:avLst/>
           </a:prstGeom>
           <a:solidFill>
-            <a:srgbClr val="6B7280"/>
+            <a:srgbClr val="059669"/>
           </a:solidFill>
           <a:ln>
             <a:noFill/>
@@ -8261,7 +8261,7 @@
                 </a:solidFill>
                 <a:latin typeface="Calibri"/>
               </a:rPr>
-              <a:t>P2</a:t>
+              <a:t>RESOLVED</a:t>
             </a:r>
           </a:p>
         </p:txBody>
@@ -8375,7 +8375,7 @@
                 </a:solidFill>
                 <a:latin typeface="Calibri"/>
               </a:rPr>
-              <a:t>Reporting propose server-side template. Billing parle de PDF FR/EN sans préciser. Foundation muet.</a:t>
+              <a:t>Reporting propose server-side template ; billing parle de PDF FR/EN sans préciser ; foundation muet. @sentropic a déjà un moteur DOCX mature (dolanmiu/docx + couche maison patchDocument, syntaxe {{...}} + boucles, Word TOC) et un PDF plus basique.</a:t>
             </a:r>
           </a:p>
         </p:txBody>
@@ -8524,7 +8524,7 @@
                 </a:solidFill>
                 <a:latin typeface="Calibri"/>
               </a:rPr>
-              <a:t>Typst ou React-PDF server-side</a:t>
+              <a:t>Extraction @sentropic : librariser docx + pdf, OpenERP consomme</a:t>
             </a:r>
           </a:p>
         </p:txBody>
@@ -8594,7 +8594,7 @@
                 </a:solidFill>
                 <a:latin typeface="Calibri"/>
               </a:rPr>
-              <a:t>Headless browser (Playwright)</a:t>
+              <a:t>Vivliostyle (CSS Paged Media, Node) — rejeté au profit de @sentropic</a:t>
             </a:r>
           </a:p>
         </p:txBody>
@@ -8664,7 +8664,7 @@
                 </a:solidFill>
                 <a:latin typeface="Calibri"/>
               </a:rPr>
-              <a:t>PDFKit programmatic</a:t>
+              <a:t>LaTeX — rejeté pour stack TS</a:t>
             </a:r>
           </a:p>
         </p:txBody>
@@ -8778,7 +8778,7 @@
                 </a:solidFill>
                 <a:latin typeface="Calibri"/>
               </a:rPr>
-              <a:t>Server-side template (Typst). Aligne reporting + billing + foundation. Évite Chromium en self-host.</a:t>
+              <a:t>✓ Arbitré 2026-05-14 : extraction @sentropic en 2 packages — @sentropic/docx-templating (extractible immédiatement) + @sentropic/pdf-templating (audit + roadmap : Paged Media, FR-CA fonts, accessibilité, templates fiscaux statutaires). OpenERP consomme via npm.</a:t>
             </a:r>
           </a:p>
         </p:txBody>
@@ -8892,7 +8892,7 @@
                 </a:solidFill>
                 <a:latin typeface="Calibri"/>
               </a:rPr>
-              <a:t>Touche reporting exports + billing invoices + foundation receipts · Décision déploiement</a:t>
+              <a:t>Touche reporting exports + billing invoices + foundation receipts · Coordination avec roadmap @sentropic</a:t>
             </a:r>
           </a:p>
         </p:txBody>
@@ -9059,7 +9059,7 @@
                 </a:solidFill>
                 <a:latin typeface="Calibri"/>
               </a:rPr>
-              <a:t>MVP Decision Pack — 2026-05-13</a:t>
+              <a:t>MVP Decision Pack — 2026-05-14</a:t>
             </a:r>
           </a:p>
         </p:txBody>
@@ -9149,7 +9149,7 @@
             <a:avLst/>
           </a:prstGeom>
           <a:solidFill>
-            <a:srgbClr val="6B7280"/>
+            <a:srgbClr val="059669"/>
           </a:solidFill>
           <a:ln>
             <a:noFill/>
@@ -9181,7 +9181,7 @@
                 </a:solidFill>
                 <a:latin typeface="Calibri"/>
               </a:rPr>
-              <a:t>P2</a:t>
+              <a:t>RESOLVED</a:t>
             </a:r>
           </a:p>
         </p:txBody>
@@ -9295,7 +9295,7 @@
                 </a:solidFill>
                 <a:latin typeface="Calibri"/>
               </a:rPr>
-              <a:t>23 hotspots consolidés (Chatter Odoo, ObjectMetadata Twenty, account_move, etc.). Aucun owner programme. Aucun script CI.</a:t>
+              <a:t>23 hotspots consolidés. Aucun owner. Aucun script CI. Précision : noms business génériques (Company, Invoice, Project, Task, Currency) ne sont pas anti-copy — une pomme est une pomme, non copyrightable.</a:t>
             </a:r>
           </a:p>
         </p:txBody>
@@ -9514,7 +9514,7 @@
                 </a:solidFill>
                 <a:latin typeface="Calibri"/>
               </a:rPr>
-              <a:t>Revue programme transverse avec ownership unique</a:t>
+              <a:t>Owner anti-copy nommé + revue par PR</a:t>
             </a:r>
           </a:p>
         </p:txBody>
@@ -9584,7 +9584,7 @@
                 </a:solidFill>
                 <a:latin typeface="Calibri"/>
               </a:rPr>
-              <a:t>Script CI grep contre tables/UI strings interdits</a:t>
+              <a:t>+ Script CI grep patterns expression-spécifiques (Odoo mail.thread, Twenty ObjectMetadata, etc.)</a:t>
             </a:r>
           </a:p>
         </p:txBody>
@@ -9698,7 +9698,7 @@
                 </a:solidFill>
                 <a:latin typeface="Calibri"/>
               </a:rPr>
-              <a:t>Combo (b) + (c) : un owner anti-copy nommé qui revoit chaque PR, plus tools/anti-copy-grep.sh CI sur les patterns interdits.</a:t>
+              <a:t>✓ Arbitré 2026-05-14 : (b) owner anti-copy + (c) tools/anti-copy-grep.sh ciblé patterns expression seulement (pas les noms génériques business). Liste précise : Odoo ir.*, account.move, mail.thread + Twenty ObjectMetadata + Frappe doctype + Kimai KEvent + SuiteCRM bean-&gt;.</a:t>
             </a:r>
           </a:p>
         </p:txBody>
@@ -10199,7 +10199,7 @@
                 </a:solidFill>
                 <a:latin typeface="Calibri"/>
               </a:rPr>
-              <a:t>MVP Decision Pack — 2026-05-13</a:t>
+              <a:t>MVP Decision Pack — 2026-05-14</a:t>
             </a:r>
           </a:p>
         </p:txBody>
@@ -10839,7 +10839,7 @@
                 </a:solidFill>
                 <a:latin typeface="Calibri"/>
               </a:rPr>
-              <a:t>Auth MVP = password + TOTP. Passkey post-MVP.</a:t>
+              <a:t>Auth MVP = passkey / WebAuthn direct (drop password + TOTP MVP)</a:t>
             </a:r>
           </a:p>
         </p:txBody>
@@ -11120,7 +11120,7 @@
                 </a:solidFill>
                 <a:latin typeface="Calibri"/>
               </a:rPr>
-              <a:t>MVP Decision Pack — 2026-05-13</a:t>
+              <a:t>MVP Decision Pack — 2026-05-14</a:t>
             </a:r>
           </a:p>
         </p:txBody>
@@ -12041,7 +12041,7 @@
                 </a:solidFill>
                 <a:latin typeface="Calibri"/>
               </a:rPr>
-              <a:t>MVP Decision Pack — 2026-05-13</a:t>
+              <a:t>MVP Decision Pack — 2026-05-14</a:t>
             </a:r>
           </a:p>
         </p:txBody>
@@ -12304,7 +12304,7 @@
                 </a:solidFill>
                 <a:latin typeface="Calibri"/>
               </a:rPr>
-              <a:t>• Decision-pack MD + PPTX généré</a:t>
+              <a:t>• Rename @entropiq → @sentropic plain MIT (30 docs)</a:t>
             </a:r>
           </a:p>
         </p:txBody>
@@ -12339,7 +12339,7 @@
                 </a:solidFill>
                 <a:latin typeface="Calibri"/>
               </a:rPr>
-              <a:t>• Rename @entropiq → @sentropic plain MIT (30 docs)</a:t>
+              <a:t>• 12 décisions programme arbitrées 2026-05-14</a:t>
             </a:r>
           </a:p>
         </p:txBody>
@@ -12374,7 +12374,7 @@
                 </a:solidFill>
                 <a:latin typeface="Calibri"/>
               </a:rPr>
-              <a:t>• Progress sections synchronisées</a:t>
+              <a:t>• Décisions gravées dans 6 specs</a:t>
             </a:r>
           </a:p>
         </p:txBody>
@@ -12532,7 +12532,7 @@
                 </a:solidFill>
                 <a:latin typeface="Calibri"/>
               </a:rPr>
-              <a:t>• Arbitrage porteur sur 6 décisions P0</a:t>
+              <a:t>• PR @sentropic : MCP + OTel + policy hooks + identité + marketplace + sandbox API</a:t>
             </a:r>
           </a:p>
         </p:txBody>
@@ -12567,7 +12567,7 @@
                 </a:solidFill>
                 <a:latin typeface="Calibri"/>
               </a:rPr>
-              <a:t>• Gravage décisions inline dans 6 specs</a:t>
+              <a:t>• Création shared-entities-v1.md (canon PG-06)</a:t>
             </a:r>
           </a:p>
         </p:txBody>
@@ -12602,7 +12602,7 @@
                 </a:solidFill>
                 <a:latin typeface="Calibri"/>
               </a:rPr>
-              <a:t>• Création NOTICE racine (Kill Bill, OpenMeter, Superset, Node-RED)</a:t>
+              <a:t>• NOTICE racine (Kill Bill, OpenMeter, Superset, Node-RED)</a:t>
             </a:r>
           </a:p>
         </p:txBody>
@@ -12637,7 +12637,7 @@
                 </a:solidFill>
                 <a:latin typeface="Calibri"/>
               </a:rPr>
-              <a:t>• Script CI anti-copy</a:t>
+              <a:t>• Script CI anti-copy (patterns expression seulement)</a:t>
             </a:r>
           </a:p>
         </p:txBody>
@@ -12672,7 +12672,7 @@
                 </a:solidFill>
                 <a:latin typeface="Calibri"/>
               </a:rPr>
-              <a:t>• Push remote (8 commits en attente)</a:t>
+              <a:t>• Foundation impl (RLS + RBAC + ICU + Money + ApprovalRequest)</a:t>
             </a:r>
           </a:p>
         </p:txBody>
@@ -12830,7 +12830,7 @@
                 </a:solidFill>
                 <a:latin typeface="Calibri"/>
               </a:rPr>
-              <a:t>• Tu arbitres via cette présentation</a:t>
+              <a:t>• Spec foundation figée → premier code</a:t>
             </a:r>
           </a:p>
         </p:txBody>
@@ -12865,7 +12865,7 @@
                 </a:solidFill>
                 <a:latin typeface="Calibri"/>
               </a:rPr>
-              <a:t>• Je grave dans les specs</a:t>
+              <a:t>• @sentropic PR ouverte, autre agent continue dev</a:t>
             </a:r>
           </a:p>
         </p:txBody>
@@ -12900,7 +12900,7 @@
                 </a:solidFill>
                 <a:latin typeface="Calibri"/>
               </a:rPr>
-              <a:t>• Passage en mode réalisation / audit</a:t>
+              <a:t>• Toi en supervision / audit</a:t>
             </a:r>
           </a:p>
         </p:txBody>
@@ -12935,7 +12935,7 @@
                 </a:solidFill>
                 <a:latin typeface="Calibri"/>
               </a:rPr>
-              <a:t>• Tu restes en supervision</a:t>
+              <a:t>• Pas de nouveau arbitrage requis avant feedback impl</a:t>
             </a:r>
           </a:p>
         </p:txBody>
@@ -13102,7 +13102,7 @@
                 </a:solidFill>
                 <a:latin typeface="Calibri"/>
               </a:rPr>
-              <a:t>MVP Decision Pack — 2026-05-13</a:t>
+              <a:t>MVP Decision Pack — 2026-05-14</a:t>
             </a:r>
           </a:p>
         </p:txBody>
@@ -14023,7 +14023,7 @@
                 </a:solidFill>
                 <a:latin typeface="Calibri"/>
               </a:rPr>
-              <a:t>MVP Decision Pack — 2026-05-13</a:t>
+              <a:t>MVP Decision Pack — 2026-05-14</a:t>
             </a:r>
           </a:p>
         </p:txBody>
@@ -14944,7 +14944,7 @@
                 </a:solidFill>
                 <a:latin typeface="Calibri"/>
               </a:rPr>
-              <a:t>MVP Decision Pack — 2026-05-13</a:t>
+              <a:t>MVP Decision Pack — 2026-05-14</a:t>
             </a:r>
           </a:p>
         </p:txBody>
@@ -15698,7 +15698,7 @@
                 </a:solidFill>
                 <a:latin typeface="Calibri"/>
               </a:rPr>
-              <a:t>Permissions = via foundation RBAC + autoriser dashboards team-scope (vs admin-curated only)</a:t>
+              <a:t>Permissions = foundation RBAC + visibility=team MVP. Rôle 'performance opérationnelle' (process défini, KPIs définis, proche mesure marché). Agent assistant aide à cadrer KPIs.</a:t>
             </a:r>
           </a:p>
         </p:txBody>
@@ -15865,7 +15865,7 @@
                 </a:solidFill>
                 <a:latin typeface="Calibri"/>
               </a:rPr>
-              <a:t>MVP Decision Pack — 2026-05-13</a:t>
+              <a:t>MVP Decision Pack — 2026-05-14</a:t>
             </a:r>
           </a:p>
         </p:txBody>
@@ -16163,7 +16163,7 @@
                 </a:solidFill>
                 <a:latin typeface="Calibri"/>
               </a:rPr>
-              <a:t>Sandbox = isolated-vm pour handlers internes signés. gVisor en pack vertical.</a:t>
+              <a:t>Sandbox = responsabilité @sentropic. OpenERP exige API sandbox + capability manifest. Feature request si manquant.</a:t>
             </a:r>
           </a:p>
         </p:txBody>
@@ -16505,7 +16505,7 @@
                 </a:solidFill>
                 <a:latin typeface="Calibri"/>
               </a:rPr>
-              <a:t>Identity agent = JWT signé (cf. PG-09)</a:t>
+              <a:t>Identity agent = RFC 8693 token exchange MVP + SPIFFE post-MVP (cf. PG-09)</a:t>
             </a:r>
           </a:p>
         </p:txBody>
@@ -16900,7 +16900,7 @@
                 </a:solidFill>
                 <a:latin typeface="Calibri"/>
               </a:rPr>
-              <a:t>MVP Decision Pack — 2026-05-13</a:t>
+              <a:t>MVP Decision Pack — 2026-05-14</a:t>
             </a:r>
           </a:p>
         </p:txBody>
@@ -17909,7 +17909,7 @@
                 </a:solidFill>
                 <a:latin typeface="Calibri"/>
               </a:rPr>
-              <a:t>MVP Decision Pack — 2026-05-13</a:t>
+              <a:t>MVP Decision Pack — 2026-05-14</a:t>
             </a:r>
           </a:p>
         </p:txBody>
@@ -19304,7 +19304,7 @@
                 </a:solidFill>
                 <a:latin typeface="Calibri"/>
               </a:rPr>
-              <a:t>MVP Decision Pack — 2026-05-13</a:t>
+              <a:t>MVP Decision Pack — 2026-05-14</a:t>
             </a:r>
           </a:p>
         </p:txBody>
@@ -22012,7 +22012,7 @@
                 </a:solidFill>
                 <a:latin typeface="Calibri"/>
               </a:rPr>
-              <a:t>Arbitre les 6 décisions P0</a:t>
+              <a:t>Arbitrage terminé</a:t>
             </a:r>
           </a:p>
         </p:txBody>
@@ -22047,7 +22047,7 @@
                 </a:solidFill>
                 <a:latin typeface="Calibri"/>
               </a:rPr>
-              <a:t>PG-02 à PG-06 + confirmation PG-07/08. Tout le code en dépend.</a:t>
+              <a:t>12 décisions programme arbitrées 2026-05-14. Décisions gravées inline dans les 6 specs MVP.</a:t>
             </a:r>
           </a:p>
         </p:txBody>
@@ -22161,7 +22161,7 @@
                 </a:solidFill>
                 <a:latin typeface="Calibri"/>
               </a:rPr>
-              <a:t>Valide le canon entités PG-06 en bloc</a:t>
+              <a:t>PR @sentropic</a:t>
             </a:r>
           </a:p>
         </p:txBody>
@@ -22196,7 +22196,7 @@
                 </a:solidFill>
                 <a:latin typeface="Calibri"/>
               </a:rPr>
-              <a:t>Organization, Money, AuditEvent / DomainEvent / TimelineEntry, Activity préfixé, frontière Project/Billing.</a:t>
+              <a:t>Ouvrir PR via ~/src/entropiq pour MCP + OTel + policy hooks + multi-tenant identity + marketplace primitives + sandbox API. Respect du plan @sentropic. L'autre agent continue le dev.</a:t>
             </a:r>
           </a:p>
         </p:txBody>
@@ -22310,7 +22310,7 @@
                 </a:solidFill>
                 <a:latin typeface="Calibri"/>
               </a:rPr>
-              <a:t>Confirme la pile technique</a:t>
+              <a:t>Implémentation foundation</a:t>
             </a:r>
           </a:p>
         </p:txBody>
@@ -22345,7 +22345,7 @@
                 </a:solidFill>
                 <a:latin typeface="Calibri"/>
               </a:rPr>
-              <a:t>PG-04 pgmq + PG-05 ICU JSON + PG-07 ApprovalRequest.</a:t>
+              <a:t>Démarrer impl foundation (UserIdentity + OrganizationMember + RLS + RBAC + ICU + Money + ApprovalRequest + Idempotency-Key) + shared-entities-v1.md.</a:t>
             </a:r>
           </a:p>
         </p:txBody>
@@ -22459,7 +22459,7 @@
                 </a:solidFill>
                 <a:latin typeface="Calibri"/>
               </a:rPr>
-              <a:t>Délègue</a:t>
+              <a:t>Mode supervision</a:t>
             </a:r>
           </a:p>
         </p:txBody>
@@ -22494,7 +22494,7 @@
                 </a:solidFill>
                 <a:latin typeface="Calibri"/>
               </a:rPr>
-              <a:t>Je grave les décisions inline dans les 6 specs. Je passe en mode réalisation / audit.</a:t>
+              <a:t>Toi en supervision / audit. Je suis en réalisation. Push à ton OK explicite.</a:t>
             </a:r>
           </a:p>
         </p:txBody>
@@ -22705,7 +22705,7 @@
                 </a:solidFill>
                 <a:latin typeface="Calibri"/>
               </a:rPr>
-              <a:t>MVP Decision Pack — 2026-05-13</a:t>
+              <a:t>MVP Decision Pack — 2026-05-14</a:t>
             </a:r>
           </a:p>
         </p:txBody>
@@ -22806,11 +22806,11 @@
             <a:r>
               <a:rPr sz="1600" b="1">
                 <a:solidFill>
-                  <a:srgbClr val="DC2626"/>
-                </a:solidFill>
-                <a:latin typeface="Calibri"/>
-              </a:rPr>
-              <a:t>Risques majeurs (réviseurs d'accord)</a:t>
+                  <a:srgbClr val="059669"/>
+                </a:solidFill>
+                <a:latin typeface="Calibri"/>
+              </a:rPr>
+              <a:t>Risques traités par l'arbitrage</a:t>
             </a:r>
           </a:p>
         </p:txBody>
@@ -22845,7 +22845,7 @@
                 </a:solidFill>
                 <a:latin typeface="Calibri"/>
               </a:rPr>
-              <a:t>1.  Pas de canon multi-tenant membership (User.organization_id casse multi-org)</a:t>
+              <a:t>1.  Multi-tenant : UserIdentity + OrganizationMember adopté (PG-02)</a:t>
             </a:r>
           </a:p>
         </p:txBody>
@@ -22880,7 +22880,7 @@
                 </a:solidFill>
                 <a:latin typeface="Calibri"/>
               </a:rPr>
-              <a:t>2.  Chaque spec choisit son scheduler/queue (3 queue engines risque)</a:t>
+              <a:t>2.  Queue : pgmq MVP + JobQueue abstrait pour migration (PG-04)</a:t>
             </a:r>
           </a:p>
         </p:txBody>
@@ -22915,7 +22915,7 @@
                 </a:solidFill>
                 <a:latin typeface="Calibri"/>
               </a:rPr>
-              <a:t>3.  Activity = fourre-tout entre CRM, project, agentic</a:t>
+              <a:t>3.  Activity : préfixage canon (CrmActivity, ProjectTask, ServiceActivity, AgentRun) (PG-06 art.3)</a:t>
             </a:r>
           </a:p>
         </p:txBody>
@@ -22950,7 +22950,7 @@
                 </a:solidFill>
                 <a:latin typeface="Calibri"/>
               </a:rPr>
-              <a:t>4.  AuditEvent / DomainEvent / TimelineEntry divergent (3 couches à séparer)</a:t>
+              <a:t>4.  Events : 3 couches séparées AuditEvent / DomainEvent / TimelineEntry (PG-06 art.2)</a:t>
             </a:r>
           </a:p>
         </p:txBody>
@@ -22985,7 +22985,7 @@
                 </a:solidFill>
                 <a:latin typeface="Calibri"/>
               </a:rPr>
-              <a:t>5.  23 anti-copy hotspots sans owner + sans script CI</a:t>
+              <a:t>5.  Anti-copy : owner nommé + script CI tools/anti-copy-grep.sh (PG-12)</a:t>
             </a:r>
           </a:p>
         </p:txBody>
@@ -23232,7 +23232,7 @@
             <a:avLst/>
           </a:prstGeom>
           <a:solidFill>
-            <a:srgbClr val="DC2626"/>
+            <a:srgbClr val="059669"/>
           </a:solidFill>
           <a:ln>
             <a:noFill/>
@@ -23264,7 +23264,7 @@
                 </a:solidFill>
                 <a:latin typeface="Calibri"/>
               </a:rPr>
-              <a:t>P0</a:t>
+              <a:t>RESOLVED</a:t>
             </a:r>
           </a:p>
         </p:txBody>
@@ -23354,7 +23354,7 @@
             <a:avLst/>
           </a:prstGeom>
           <a:solidFill>
-            <a:srgbClr val="DC2626"/>
+            <a:srgbClr val="059669"/>
           </a:solidFill>
           <a:ln>
             <a:noFill/>
@@ -23386,7 +23386,7 @@
                 </a:solidFill>
                 <a:latin typeface="Calibri"/>
               </a:rPr>
-              <a:t>P0</a:t>
+              <a:t>RESOLVED</a:t>
             </a:r>
           </a:p>
         </p:txBody>
@@ -23476,7 +23476,7 @@
             <a:avLst/>
           </a:prstGeom>
           <a:solidFill>
-            <a:srgbClr val="DC2626"/>
+            <a:srgbClr val="059669"/>
           </a:solidFill>
           <a:ln>
             <a:noFill/>
@@ -23508,7 +23508,7 @@
                 </a:solidFill>
                 <a:latin typeface="Calibri"/>
               </a:rPr>
-              <a:t>P0</a:t>
+              <a:t>RESOLVED</a:t>
             </a:r>
           </a:p>
         </p:txBody>
@@ -23598,7 +23598,7 @@
             <a:avLst/>
           </a:prstGeom>
           <a:solidFill>
-            <a:srgbClr val="DC2626"/>
+            <a:srgbClr val="059669"/>
           </a:solidFill>
           <a:ln>
             <a:noFill/>
@@ -23630,7 +23630,7 @@
                 </a:solidFill>
                 <a:latin typeface="Calibri"/>
               </a:rPr>
-              <a:t>P0</a:t>
+              <a:t>RESOLVED</a:t>
             </a:r>
           </a:p>
         </p:txBody>
@@ -23720,7 +23720,7 @@
             <a:avLst/>
           </a:prstGeom>
           <a:solidFill>
-            <a:srgbClr val="DC2626"/>
+            <a:srgbClr val="059669"/>
           </a:solidFill>
           <a:ln>
             <a:noFill/>
@@ -23752,7 +23752,7 @@
                 </a:solidFill>
                 <a:latin typeface="Calibri"/>
               </a:rPr>
-              <a:t>P0</a:t>
+              <a:t>RESOLVED</a:t>
             </a:r>
           </a:p>
         </p:txBody>
@@ -23842,7 +23842,7 @@
             <a:avLst/>
           </a:prstGeom>
           <a:solidFill>
-            <a:srgbClr val="D97606"/>
+            <a:srgbClr val="059669"/>
           </a:solidFill>
           <a:ln>
             <a:noFill/>
@@ -23874,7 +23874,7 @@
                 </a:solidFill>
                 <a:latin typeface="Calibri"/>
               </a:rPr>
-              <a:t>P1</a:t>
+              <a:t>RESOLVED</a:t>
             </a:r>
           </a:p>
         </p:txBody>
@@ -23964,7 +23964,7 @@
             <a:avLst/>
           </a:prstGeom>
           <a:solidFill>
-            <a:srgbClr val="D97606"/>
+            <a:srgbClr val="059669"/>
           </a:solidFill>
           <a:ln>
             <a:noFill/>
@@ -23996,7 +23996,7 @@
                 </a:solidFill>
                 <a:latin typeface="Calibri"/>
               </a:rPr>
-              <a:t>P1</a:t>
+              <a:t>RESOLVED</a:t>
             </a:r>
           </a:p>
         </p:txBody>
@@ -24066,7 +24066,7 @@
                 </a:solidFill>
                 <a:latin typeface="Calibri"/>
               </a:rPr>
-              <a:t>Identité agent</a:t>
+              <a:t>Identité agent + délégation</a:t>
             </a:r>
           </a:p>
         </p:txBody>
@@ -24086,7 +24086,7 @@
             <a:avLst/>
           </a:prstGeom>
           <a:solidFill>
-            <a:srgbClr val="D97606"/>
+            <a:srgbClr val="059669"/>
           </a:solidFill>
           <a:ln>
             <a:noFill/>
@@ -24118,7 +24118,7 @@
                 </a:solidFill>
                 <a:latin typeface="Calibri"/>
               </a:rPr>
-              <a:t>P1</a:t>
+              <a:t>RESOLVED</a:t>
             </a:r>
           </a:p>
         </p:txBody>
@@ -24208,7 +24208,7 @@
             <a:avLst/>
           </a:prstGeom>
           <a:solidFill>
-            <a:srgbClr val="D97606"/>
+            <a:srgbClr val="059669"/>
           </a:solidFill>
           <a:ln>
             <a:noFill/>
@@ -24240,7 +24240,7 @@
                 </a:solidFill>
                 <a:latin typeface="Calibri"/>
               </a:rPr>
-              <a:t>P1</a:t>
+              <a:t>RESOLVED</a:t>
             </a:r>
           </a:p>
         </p:txBody>
@@ -24310,7 +24310,7 @@
                 </a:solidFill>
                 <a:latin typeface="Calibri"/>
               </a:rPr>
-              <a:t>Stack PDF rendering</a:t>
+              <a:t>Stack templating (docx + pdf)</a:t>
             </a:r>
           </a:p>
         </p:txBody>
@@ -24330,7 +24330,7 @@
             <a:avLst/>
           </a:prstGeom>
           <a:solidFill>
-            <a:srgbClr val="6B7280"/>
+            <a:srgbClr val="059669"/>
           </a:solidFill>
           <a:ln>
             <a:noFill/>
@@ -24362,7 +24362,7 @@
                 </a:solidFill>
                 <a:latin typeface="Calibri"/>
               </a:rPr>
-              <a:t>P2</a:t>
+              <a:t>RESOLVED</a:t>
             </a:r>
           </a:p>
         </p:txBody>
@@ -24452,7 +24452,7 @@
             <a:avLst/>
           </a:prstGeom>
           <a:solidFill>
-            <a:srgbClr val="6B7280"/>
+            <a:srgbClr val="059669"/>
           </a:solidFill>
           <a:ln>
             <a:noFill/>
@@ -24484,7 +24484,7 @@
                 </a:solidFill>
                 <a:latin typeface="Calibri"/>
               </a:rPr>
-              <a:t>P2</a:t>
+              <a:t>RESOLVED</a:t>
             </a:r>
           </a:p>
         </p:txBody>
@@ -24695,7 +24695,7 @@
                 </a:solidFill>
                 <a:latin typeface="Calibri"/>
               </a:rPr>
-              <a:t>12 décisions transverses · 1 résolue · 5 P0 bloquantes</a:t>
+              <a:t>12 décisions transverses · toutes arbitrées 2026-05-14</a:t>
             </a:r>
           </a:p>
         </p:txBody>
@@ -24871,7 +24871,7 @@
                 </a:solidFill>
                 <a:latin typeface="Calibri"/>
               </a:rPr>
-              <a:t>MVP Decision Pack — 2026-05-13</a:t>
+              <a:t>MVP Decision Pack — 2026-05-14</a:t>
             </a:r>
           </a:p>
         </p:txBody>
@@ -25791,7 +25791,7 @@
                 </a:solidFill>
                 <a:latin typeface="Calibri"/>
               </a:rPr>
-              <a:t>MVP Decision Pack — 2026-05-13</a:t>
+              <a:t>MVP Decision Pack — 2026-05-14</a:t>
             </a:r>
           </a:p>
         </p:txBody>
@@ -25881,7 +25881,7 @@
             <a:avLst/>
           </a:prstGeom>
           <a:solidFill>
-            <a:srgbClr val="DC2626"/>
+            <a:srgbClr val="059669"/>
           </a:solidFill>
           <a:ln>
             <a:noFill/>
@@ -25913,7 +25913,7 @@
                 </a:solidFill>
                 <a:latin typeface="Calibri"/>
               </a:rPr>
-              <a:t>P0</a:t>
+              <a:t>RESOLVED</a:t>
             </a:r>
           </a:p>
         </p:txBody>
@@ -26430,7 +26430,7 @@
                 </a:solidFill>
                 <a:latin typeface="Calibri"/>
               </a:rPr>
-              <a:t>Option (a) UserIdentity + OrganizationMember si humains multi-org attendus ; sinon (b) plus simple mais friction utilisateur quand multi-tenant arrive.</a:t>
+              <a:t>✓ Arbitré 2026-05-14 : option (a) UserIdentity + OrganizationMember. Multi-tenant dès MVP, refactor FK et JWT en conséquence.</a:t>
             </a:r>
           </a:p>
         </p:txBody>
@@ -26711,7 +26711,7 @@
                 </a:solidFill>
                 <a:latin typeface="Calibri"/>
               </a:rPr>
-              <a:t>MVP Decision Pack — 2026-05-13</a:t>
+              <a:t>MVP Decision Pack — 2026-05-14</a:t>
             </a:r>
           </a:p>
         </p:txBody>
@@ -26801,7 +26801,7 @@
             <a:avLst/>
           </a:prstGeom>
           <a:solidFill>
-            <a:srgbClr val="DC2626"/>
+            <a:srgbClr val="059669"/>
           </a:solidFill>
           <a:ln>
             <a:noFill/>
@@ -26833,7 +26833,7 @@
                 </a:solidFill>
                 <a:latin typeface="Calibri"/>
               </a:rPr>
-              <a:t>P0</a:t>
+              <a:t>RESOLVED</a:t>
             </a:r>
           </a:p>
         </p:txBody>
@@ -27350,7 +27350,7 @@
                 </a:solidFill>
                 <a:latin typeface="Calibri"/>
               </a:rPr>
-              <a:t>Row-level + Postgres RLS. Défense en profondeur, scaling acceptable, pattern standard.</a:t>
+              <a:t>✓ Arbitré 2026-05-14 : (a) RLS row-level MVP, avec abstraction TenantIsolationStrategy supportant (a/b/c) dès le contrat foundation. Switch par config sans réécriture downstream.</a:t>
             </a:r>
           </a:p>
         </p:txBody>
@@ -27631,7 +27631,7 @@
                 </a:solidFill>
                 <a:latin typeface="Calibri"/>
               </a:rPr>
-              <a:t>MVP Decision Pack — 2026-05-13</a:t>
+              <a:t>MVP Decision Pack — 2026-05-14</a:t>
             </a:r>
           </a:p>
         </p:txBody>
@@ -27721,7 +27721,7 @@
             <a:avLst/>
           </a:prstGeom>
           <a:solidFill>
-            <a:srgbClr val="DC2626"/>
+            <a:srgbClr val="059669"/>
           </a:solidFill>
           <a:ln>
             <a:noFill/>
@@ -27753,7 +27753,7 @@
                 </a:solidFill>
                 <a:latin typeface="Calibri"/>
               </a:rPr>
-              <a:t>P0</a:t>
+              <a:t>RESOLVED</a:t>
             </a:r>
           </a:p>
         </p:txBody>
@@ -28340,7 +28340,7 @@
                 </a:solidFill>
                 <a:latin typeface="Calibri"/>
               </a:rPr>
-              <a:t>pgmq pour MVP self-host. Interface JobQueue abstraite pour migration future si volumétrie l'exige.</a:t>
+              <a:t>✓ Arbitré 2026-05-14 : (a) pgmq MVP, avec interface JobQueue abstraite supportant (a/b/c). Adapter pattern, scheduler ne touche jamais pgmq directement.</a:t>
             </a:r>
           </a:p>
         </p:txBody>
@@ -28454,7 +28454,7 @@
                 </a:solidFill>
                 <a:latin typeface="Calibri"/>
               </a:rPr>
-              <a:t>Touche billing récurrent + reporting scheduled + agentic runs · Pas d'arbitrage P0 → 3 queues séparées</a:t>
+              <a:t>Touche billing récurrent + reporting scheduled + agentic runs · 3 implémentations possibles via le même contrat</a:t>
             </a:r>
           </a:p>
         </p:txBody>
@@ -28621,7 +28621,7 @@
                 </a:solidFill>
                 <a:latin typeface="Calibri"/>
               </a:rPr>
-              <a:t>MVP Decision Pack — 2026-05-13</a:t>
+              <a:t>MVP Decision Pack — 2026-05-14</a:t>
             </a:r>
           </a:p>
         </p:txBody>
@@ -28711,7 +28711,7 @@
             <a:avLst/>
           </a:prstGeom>
           <a:solidFill>
-            <a:srgbClr val="DC2626"/>
+            <a:srgbClr val="059669"/>
           </a:solidFill>
           <a:ln>
             <a:noFill/>
@@ -28743,7 +28743,7 @@
                 </a:solidFill>
                 <a:latin typeface="Calibri"/>
               </a:rPr>
-              <a:t>P0</a:t>
+              <a:t>RESOLVED</a:t>
             </a:r>
           </a:p>
         </p:txBody>

</xml_diff>